<commit_message>
Deployed c9794b0 with MkDocs version: 1.6.1
</commit_message>
<xml_diff>
--- a/tema0/diapositivas/dev-containers.pptx
+++ b/tema0/diapositivas/dev-containers.pptx
@@ -5,7 +5,7 @@
     <p:sldMasterId id="2147483648" r:id="rId1"/>
   </p:sldMasterIdLst>
   <p:notesMasterIdLst>
-    <p:notesMasterId r:id="rId12"/>
+    <p:notesMasterId r:id="rId9"/>
   </p:notesMasterIdLst>
   <p:sldIdLst>
     <p:sldId id="256" r:id="rId2"/>
@@ -15,9 +15,6 @@
     <p:sldId id="260" r:id="rId6"/>
     <p:sldId id="261" r:id="rId7"/>
     <p:sldId id="262" r:id="rId8"/>
-    <p:sldId id="263" r:id="rId9"/>
-    <p:sldId id="264" r:id="rId10"/>
-    <p:sldId id="265" r:id="rId11"/>
   </p:sldIdLst>
   <p:sldSz cx="12192000" cy="6858000"/>
   <p:notesSz cx="6858000" cy="12192000"/>
@@ -146,7 +143,7 @@
     </p:spTree>
     <p:extLst>
       <p:ext uri="{BB962C8B-B14F-4D97-AF65-F5344CB8AC3E}">
-        <p14:creationId xmlns:p14="http://schemas.microsoft.com/office/powerpoint/2010/main" val="1807467740"/>
+        <p14:creationId xmlns:p14="http://schemas.microsoft.com/office/powerpoint/2010/main" val="428582844"/>
       </p:ext>
     </p:extLst>
   </p:cSld>
@@ -330,90 +327,6 @@
 </p:notes>
 </file>
 
-<file path=ppt/notesSlides/notesSlide10.xml><?xml version="1.0" encoding="utf-8"?>
-<p:notes xmlns:a="http://schemas.openxmlformats.org/drawingml/2006/main" xmlns:r="http://schemas.openxmlformats.org/officeDocument/2006/relationships" xmlns:p="http://schemas.openxmlformats.org/presentationml/2006/main">
-  <p:cSld>
-    <p:spTree>
-      <p:nvGrpSpPr>
-        <p:cNvPr id="1" name=""/>
-        <p:cNvGrpSpPr/>
-        <p:nvPr/>
-      </p:nvGrpSpPr>
-      <p:grpSpPr>
-        <a:xfrm>
-          <a:off x="0" y="0"/>
-          <a:ext cx="0" cy="0"/>
-          <a:chOff x="0" y="0"/>
-          <a:chExt cx="0" cy="0"/>
-        </a:xfrm>
-      </p:grpSpPr>
-      <p:sp>
-        <p:nvSpPr>
-          <p:cNvPr id="2" name="Slide Image Placeholder 1"/>
-          <p:cNvSpPr>
-            <a:spLocks noGrp="1" noRot="1" noChangeAspect="1"/>
-          </p:cNvSpPr>
-          <p:nvPr>
-            <p:ph type="sldImg"/>
-          </p:nvPr>
-        </p:nvSpPr>
-        <p:spPr/>
-      </p:sp>
-      <p:sp>
-        <p:nvSpPr>
-          <p:cNvPr id="3" name="Notes Placeholder 2"/>
-          <p:cNvSpPr>
-            <a:spLocks noGrp="1"/>
-          </p:cNvSpPr>
-          <p:nvPr>
-            <p:ph type="body" idx="1"/>
-          </p:nvPr>
-        </p:nvSpPr>
-        <p:spPr/>
-        <p:txBody>
-          <a:bodyPr/>
-          <a:lstStyle/>
-          <a:p>
-            <a:endParaRPr lang="en-US" dirty="0"/>
-          </a:p>
-        </p:txBody>
-      </p:sp>
-      <p:sp>
-        <p:nvSpPr>
-          <p:cNvPr id="4" name="Slide Number Placeholder 3"/>
-          <p:cNvSpPr>
-            <a:spLocks noGrp="1"/>
-          </p:cNvSpPr>
-          <p:nvPr>
-            <p:ph type="sldNum" sz="quarter" idx="10"/>
-          </p:nvPr>
-        </p:nvSpPr>
-        <p:spPr/>
-        <p:txBody>
-          <a:bodyPr/>
-          <a:lstStyle/>
-          <a:p>
-            <a:fld id="{F7021451-1387-4CA6-816F-3879F97B5CBC}" type="slidenum">
-              <a:rPr lang="en-US"/>
-              <a:t>10</a:t>
-            </a:fld>
-            <a:endParaRPr lang="en-US"/>
-          </a:p>
-        </p:txBody>
-      </p:sp>
-    </p:spTree>
-    <p:extLst>
-      <p:ext uri="{BB962C8B-B14F-4D97-AF65-F5344CB8AC3E}">
-        <p14:creationId xmlns:p14="http://schemas.microsoft.com/office/powerpoint/2010/main" val="1024086991"/>
-      </p:ext>
-    </p:extLst>
-  </p:cSld>
-  <p:clrMapOvr>
-    <a:masterClrMapping/>
-  </p:clrMapOvr>
-</p:notes>
-</file>
-
 <file path=ppt/notesSlides/notesSlide2.xml><?xml version="1.0" encoding="utf-8"?>
 <p:notes xmlns:a="http://schemas.openxmlformats.org/drawingml/2006/main" xmlns:r="http://schemas.openxmlformats.org/officeDocument/2006/relationships" xmlns:p="http://schemas.openxmlformats.org/presentationml/2006/main">
   <p:cSld>
@@ -900,174 +813,6 @@
             <a:fld id="{F7021451-1387-4CA6-816F-3879F97B5CBC}" type="slidenum">
               <a:rPr lang="en-US"/>
               <a:t>7</a:t>
-            </a:fld>
-            <a:endParaRPr lang="en-US"/>
-          </a:p>
-        </p:txBody>
-      </p:sp>
-    </p:spTree>
-    <p:extLst>
-      <p:ext uri="{BB962C8B-B14F-4D97-AF65-F5344CB8AC3E}">
-        <p14:creationId xmlns:p14="http://schemas.microsoft.com/office/powerpoint/2010/main" val="1024086991"/>
-      </p:ext>
-    </p:extLst>
-  </p:cSld>
-  <p:clrMapOvr>
-    <a:masterClrMapping/>
-  </p:clrMapOvr>
-</p:notes>
-</file>
-
-<file path=ppt/notesSlides/notesSlide8.xml><?xml version="1.0" encoding="utf-8"?>
-<p:notes xmlns:a="http://schemas.openxmlformats.org/drawingml/2006/main" xmlns:r="http://schemas.openxmlformats.org/officeDocument/2006/relationships" xmlns:p="http://schemas.openxmlformats.org/presentationml/2006/main">
-  <p:cSld>
-    <p:spTree>
-      <p:nvGrpSpPr>
-        <p:cNvPr id="1" name=""/>
-        <p:cNvGrpSpPr/>
-        <p:nvPr/>
-      </p:nvGrpSpPr>
-      <p:grpSpPr>
-        <a:xfrm>
-          <a:off x="0" y="0"/>
-          <a:ext cx="0" cy="0"/>
-          <a:chOff x="0" y="0"/>
-          <a:chExt cx="0" cy="0"/>
-        </a:xfrm>
-      </p:grpSpPr>
-      <p:sp>
-        <p:nvSpPr>
-          <p:cNvPr id="2" name="Slide Image Placeholder 1"/>
-          <p:cNvSpPr>
-            <a:spLocks noGrp="1" noRot="1" noChangeAspect="1"/>
-          </p:cNvSpPr>
-          <p:nvPr>
-            <p:ph type="sldImg"/>
-          </p:nvPr>
-        </p:nvSpPr>
-        <p:spPr/>
-      </p:sp>
-      <p:sp>
-        <p:nvSpPr>
-          <p:cNvPr id="3" name="Notes Placeholder 2"/>
-          <p:cNvSpPr>
-            <a:spLocks noGrp="1"/>
-          </p:cNvSpPr>
-          <p:nvPr>
-            <p:ph type="body" idx="1"/>
-          </p:nvPr>
-        </p:nvSpPr>
-        <p:spPr/>
-        <p:txBody>
-          <a:bodyPr/>
-          <a:lstStyle/>
-          <a:p>
-            <a:endParaRPr lang="en-US" dirty="0"/>
-          </a:p>
-        </p:txBody>
-      </p:sp>
-      <p:sp>
-        <p:nvSpPr>
-          <p:cNvPr id="4" name="Slide Number Placeholder 3"/>
-          <p:cNvSpPr>
-            <a:spLocks noGrp="1"/>
-          </p:cNvSpPr>
-          <p:nvPr>
-            <p:ph type="sldNum" sz="quarter" idx="10"/>
-          </p:nvPr>
-        </p:nvSpPr>
-        <p:spPr/>
-        <p:txBody>
-          <a:bodyPr/>
-          <a:lstStyle/>
-          <a:p>
-            <a:fld id="{F7021451-1387-4CA6-816F-3879F97B5CBC}" type="slidenum">
-              <a:rPr lang="en-US"/>
-              <a:t>8</a:t>
-            </a:fld>
-            <a:endParaRPr lang="en-US"/>
-          </a:p>
-        </p:txBody>
-      </p:sp>
-    </p:spTree>
-    <p:extLst>
-      <p:ext uri="{BB962C8B-B14F-4D97-AF65-F5344CB8AC3E}">
-        <p14:creationId xmlns:p14="http://schemas.microsoft.com/office/powerpoint/2010/main" val="1024086991"/>
-      </p:ext>
-    </p:extLst>
-  </p:cSld>
-  <p:clrMapOvr>
-    <a:masterClrMapping/>
-  </p:clrMapOvr>
-</p:notes>
-</file>
-
-<file path=ppt/notesSlides/notesSlide9.xml><?xml version="1.0" encoding="utf-8"?>
-<p:notes xmlns:a="http://schemas.openxmlformats.org/drawingml/2006/main" xmlns:r="http://schemas.openxmlformats.org/officeDocument/2006/relationships" xmlns:p="http://schemas.openxmlformats.org/presentationml/2006/main">
-  <p:cSld>
-    <p:spTree>
-      <p:nvGrpSpPr>
-        <p:cNvPr id="1" name=""/>
-        <p:cNvGrpSpPr/>
-        <p:nvPr/>
-      </p:nvGrpSpPr>
-      <p:grpSpPr>
-        <a:xfrm>
-          <a:off x="0" y="0"/>
-          <a:ext cx="0" cy="0"/>
-          <a:chOff x="0" y="0"/>
-          <a:chExt cx="0" cy="0"/>
-        </a:xfrm>
-      </p:grpSpPr>
-      <p:sp>
-        <p:nvSpPr>
-          <p:cNvPr id="2" name="Slide Image Placeholder 1"/>
-          <p:cNvSpPr>
-            <a:spLocks noGrp="1" noRot="1" noChangeAspect="1"/>
-          </p:cNvSpPr>
-          <p:nvPr>
-            <p:ph type="sldImg"/>
-          </p:nvPr>
-        </p:nvSpPr>
-        <p:spPr/>
-      </p:sp>
-      <p:sp>
-        <p:nvSpPr>
-          <p:cNvPr id="3" name="Notes Placeholder 2"/>
-          <p:cNvSpPr>
-            <a:spLocks noGrp="1"/>
-          </p:cNvSpPr>
-          <p:nvPr>
-            <p:ph type="body" idx="1"/>
-          </p:nvPr>
-        </p:nvSpPr>
-        <p:spPr/>
-        <p:txBody>
-          <a:bodyPr/>
-          <a:lstStyle/>
-          <a:p>
-            <a:endParaRPr lang="en-US" dirty="0"/>
-          </a:p>
-        </p:txBody>
-      </p:sp>
-      <p:sp>
-        <p:nvSpPr>
-          <p:cNvPr id="4" name="Slide Number Placeholder 3"/>
-          <p:cNvSpPr>
-            <a:spLocks noGrp="1"/>
-          </p:cNvSpPr>
-          <p:nvPr>
-            <p:ph type="sldNum" sz="quarter" idx="10"/>
-          </p:nvPr>
-        </p:nvSpPr>
-        <p:spPr/>
-        <p:txBody>
-          <a:bodyPr/>
-          <a:lstStyle/>
-          <a:p>
-            <a:fld id="{F7021451-1387-4CA6-816F-3879F97B5CBC}" type="slidenum">
-              <a:rPr lang="en-US"/>
-              <a:t>9</a:t>
             </a:fld>
             <a:endParaRPr lang="en-US"/>
           </a:p>
@@ -1580,247 +1325,6 @@
 </p:sld>
 </file>
 
-<file path=ppt/slides/slide10.xml><?xml version="1.0" encoding="utf-8"?>
-<p:sld xmlns:a="http://schemas.openxmlformats.org/drawingml/2006/main" xmlns:r="http://schemas.openxmlformats.org/officeDocument/2006/relationships" xmlns:p="http://schemas.openxmlformats.org/presentationml/2006/main">
-  <p:cSld name="Slide 10">
-    <p:spTree>
-      <p:nvGrpSpPr>
-        <p:cNvPr id="1" name=""/>
-        <p:cNvGrpSpPr/>
-        <p:nvPr/>
-      </p:nvGrpSpPr>
-      <p:grpSpPr>
-        <a:xfrm>
-          <a:off x="0" y="0"/>
-          <a:ext cx="0" cy="0"/>
-          <a:chOff x="0" y="0"/>
-          <a:chExt cx="0" cy="0"/>
-        </a:xfrm>
-      </p:grpSpPr>
-      <p:sp>
-        <p:nvSpPr>
-          <p:cNvPr id="2" name="Shape 0"/>
-          <p:cNvSpPr/>
-          <p:nvPr/>
-        </p:nvSpPr>
-        <p:spPr>
-          <a:xfrm>
-            <a:off x="0" y="0"/>
-            <a:ext cx="12188952" cy="777240"/>
-          </a:xfrm>
-          <a:prstGeom prst="rect">
-            <a:avLst/>
-          </a:prstGeom>
-          <a:solidFill>
-            <a:srgbClr val="7F0000"/>
-          </a:solidFill>
-          <a:ln w="12700">
-            <a:solidFill>
-              <a:srgbClr val="7F0000"/>
-            </a:solidFill>
-            <a:prstDash val="solid"/>
-          </a:ln>
-        </p:spPr>
-        <p:txBody>
-          <a:bodyPr/>
-          <a:lstStyle/>
-          <a:p>
-            <a:endParaRPr lang="es-ES"/>
-          </a:p>
-        </p:txBody>
-      </p:sp>
-      <p:sp>
-        <p:nvSpPr>
-          <p:cNvPr id="3" name="Text 1"/>
-          <p:cNvSpPr/>
-          <p:nvPr/>
-        </p:nvSpPr>
-        <p:spPr>
-          <a:xfrm>
-            <a:off x="365760" y="0"/>
-            <a:ext cx="11457432" cy="777240"/>
-          </a:xfrm>
-          <a:prstGeom prst="rect">
-            <a:avLst/>
-          </a:prstGeom>
-          <a:noFill/>
-          <a:ln/>
-        </p:spPr>
-        <p:txBody>
-          <a:bodyPr wrap="square" rtlCol="0" anchor="ctr"/>
-          <a:lstStyle/>
-          <a:p>
-            <a:pPr marL="0" indent="0">
-              <a:buNone/>
-            </a:pPr>
-            <a:r>
-              <a:rPr lang="en-US" sz="2600" b="1" dirty="0">
-                <a:solidFill>
-                  <a:srgbClr val="FFFFFF"/>
-                </a:solidFill>
-                <a:latin typeface="Arial" pitchFamily="34" charset="0"/>
-                <a:ea typeface="Arial" pitchFamily="34" charset="-122"/>
-                <a:cs typeface="Arial" pitchFamily="34" charset="-120"/>
-              </a:rPr>
-              <a:t>Ideas clave</a:t>
-            </a:r>
-            <a:endParaRPr lang="en-US" sz="2600" dirty="0"/>
-          </a:p>
-        </p:txBody>
-      </p:sp>
-      <p:sp>
-        <p:nvSpPr>
-          <p:cNvPr id="4" name="Text 2"/>
-          <p:cNvSpPr/>
-          <p:nvPr/>
-        </p:nvSpPr>
-        <p:spPr>
-          <a:xfrm>
-            <a:off x="548640" y="6473952"/>
-            <a:ext cx="11091672" cy="292608"/>
-          </a:xfrm>
-          <a:prstGeom prst="rect">
-            <a:avLst/>
-          </a:prstGeom>
-          <a:noFill/>
-          <a:ln/>
-        </p:spPr>
-        <p:txBody>
-          <a:bodyPr wrap="square" rtlCol="0" anchor="ctr"/>
-          <a:lstStyle/>
-          <a:p>
-            <a:pPr marL="0" indent="0" algn="r">
-              <a:buNone/>
-            </a:pPr>
-            <a:r>
-              <a:rPr lang="en-US" sz="1100" dirty="0">
-                <a:solidFill>
-                  <a:srgbClr val="757575"/>
-                </a:solidFill>
-                <a:latin typeface="Arial" pitchFamily="34" charset="0"/>
-                <a:ea typeface="Arial" pitchFamily="34" charset="-122"/>
-                <a:cs typeface="Arial" pitchFamily="34" charset="-120"/>
-              </a:rPr>
-              <a:t>Acceso a Datos — Dev Containers</a:t>
-            </a:r>
-            <a:endParaRPr lang="en-US" sz="1100" dirty="0"/>
-          </a:p>
-        </p:txBody>
-      </p:sp>
-      <p:sp>
-        <p:nvSpPr>
-          <p:cNvPr id="5" name="Text 3"/>
-          <p:cNvSpPr/>
-          <p:nvPr/>
-        </p:nvSpPr>
-        <p:spPr>
-          <a:xfrm>
-            <a:off x="548640" y="1675778"/>
-            <a:ext cx="11091672" cy="4572000"/>
-          </a:xfrm>
-          <a:prstGeom prst="rect">
-            <a:avLst/>
-          </a:prstGeom>
-          <a:noFill/>
-          <a:ln/>
-        </p:spPr>
-        <p:txBody>
-          <a:bodyPr wrap="square" rtlCol="0" anchor="t"/>
-          <a:lstStyle/>
-          <a:p>
-            <a:pPr marL="190500" indent="-190500">
-              <a:spcAft>
-                <a:spcPts val="2400"/>
-              </a:spcAft>
-              <a:buSzPct val="100000"/>
-              <a:buChar char="•"/>
-            </a:pPr>
-            <a:r>
-              <a:rPr lang="en-US" sz="2300" dirty="0">
-                <a:solidFill>
-                  <a:srgbClr val="212121"/>
-                </a:solidFill>
-                <a:latin typeface="Arial" pitchFamily="34" charset="0"/>
-                <a:ea typeface="Arial" pitchFamily="34" charset="-122"/>
-                <a:cs typeface="Arial" pitchFamily="34" charset="-120"/>
-              </a:rPr>
-              <a:t>Un Dev Container usa Docker para alojar tu propio entorno de programación, no un servicio.</a:t>
-            </a:r>
-            <a:endParaRPr lang="en-US" sz="2300" dirty="0"/>
-          </a:p>
-          <a:p>
-            <a:pPr marL="190500" indent="-190500">
-              <a:spcAft>
-                <a:spcPts val="2400"/>
-              </a:spcAft>
-              <a:buSzPct val="100000"/>
-              <a:buChar char="•"/>
-            </a:pPr>
-            <a:r>
-              <a:rPr lang="en-US" sz="2300" dirty="0">
-                <a:solidFill>
-                  <a:srgbClr val="212121"/>
-                </a:solidFill>
-                <a:latin typeface="Arial" pitchFamily="34" charset="0"/>
-                <a:ea typeface="Arial" pitchFamily="34" charset="-122"/>
-                <a:cs typeface="Arial" pitchFamily="34" charset="-120"/>
-              </a:rPr>
-              <a:t>Tu editor se conecta directamente dentro, guiado por un fichero .devcontainer/devcontainer.json.</a:t>
-            </a:r>
-            <a:endParaRPr lang="en-US" sz="2300" dirty="0"/>
-          </a:p>
-          <a:p>
-            <a:pPr marL="190500" indent="-190500">
-              <a:spcAft>
-                <a:spcPts val="2400"/>
-              </a:spcAft>
-              <a:buSzPct val="100000"/>
-              <a:buChar char="•"/>
-            </a:pPr>
-            <a:r>
-              <a:rPr lang="en-US" sz="2300" dirty="0">
-                <a:solidFill>
-                  <a:srgbClr val="212121"/>
-                </a:solidFill>
-                <a:latin typeface="Arial" pitchFamily="34" charset="0"/>
-                <a:ea typeface="Arial" pitchFamily="34" charset="-122"/>
-                <a:cs typeface="Arial" pitchFamily="34" charset="-120"/>
-              </a:rPr>
-              <a:t>La ventana del editor no cambia de aspecto: lo que cambia es dónde corren de verdad la terminal, el depurador y el autocompletado.</a:t>
-            </a:r>
-            <a:endParaRPr lang="en-US" sz="2300" dirty="0"/>
-          </a:p>
-          <a:p>
-            <a:pPr marL="190500" indent="-190500">
-              <a:spcAft>
-                <a:spcPts val="2400"/>
-              </a:spcAft>
-              <a:buSzPct val="100000"/>
-              <a:buChar char="•"/>
-            </a:pPr>
-            <a:r>
-              <a:rPr lang="en-US" sz="2300" dirty="0">
-                <a:solidFill>
-                  <a:srgbClr val="212121"/>
-                </a:solidFill>
-                <a:latin typeface="Arial" pitchFamily="34" charset="0"/>
-                <a:ea typeface="Arial" pitchFamily="34" charset="-122"/>
-                <a:cs typeface="Arial" pitchFamily="34" charset="-120"/>
-              </a:rPr>
-              <a:t>El devcontainer.json puede construir el entorno a partir de una image suelta, o de un servicio dentro de un docker-compose.yml ya existente.</a:t>
-            </a:r>
-            <a:endParaRPr lang="en-US" sz="2300" dirty="0"/>
-          </a:p>
-        </p:txBody>
-      </p:sp>
-    </p:spTree>
-  </p:cSld>
-  <p:clrMapOvr>
-    <a:masterClrMapping/>
-  </p:clrMapOvr>
-</p:sld>
-</file>
-
 <file path=ppt/slides/slide2.xml><?xml version="1.0" encoding="utf-8"?>
 <p:sld xmlns:a="http://schemas.openxmlformats.org/drawingml/2006/main" xmlns:r="http://schemas.openxmlformats.org/officeDocument/2006/relationships" xmlns:p="http://schemas.openxmlformats.org/presentationml/2006/main">
   <p:cSld name="Slide 2">
@@ -1956,8 +1460,8 @@
         </p:nvSpPr>
         <p:spPr>
           <a:xfrm>
-            <a:off x="548640" y="1508760"/>
-            <a:ext cx="11091672" cy="1920240"/>
+            <a:off x="548640" y="1005840"/>
+            <a:ext cx="11091672" cy="1371600"/>
           </a:xfrm>
           <a:prstGeom prst="rect">
             <a:avLst/>
@@ -1973,7 +1477,7 @@
               <a:buNone/>
             </a:pPr>
             <a:r>
-              <a:rPr lang="en-US" sz="2300" dirty="0">
+              <a:rPr lang="en-US" sz="2000" dirty="0">
                 <a:solidFill>
                   <a:srgbClr val="212121"/>
                 </a:solidFill>
@@ -1981,22 +1485,86 @@
                 <a:ea typeface="Arial" pitchFamily="34" charset="-122"/>
                 <a:cs typeface="Arial" pitchFamily="34" charset="-120"/>
               </a:rPr>
-              <a:t>Instalar Java, Node o cualquier herramienta del curso directamente en tu ordenador tiene los mismos problemas que ya has visto con Docker: una versión distinta a la de tu compañero, un sistema operativo distinto, media mañana perdida configurando un portátil nuevo.</a:t>
+              <a:t>Instalar Java, Node o cualquier herramienta del curso directamente en tu ordenador tiene los mismos problemas que con Docker: una versión distinta a la de tu compañero, otro sistema operativo, media mañana perdida configurando un portátil nuevo.</a:t>
             </a:r>
-            <a:endParaRPr lang="en-US" sz="2300" dirty="0"/>
-          </a:p>
-        </p:txBody>
-      </p:sp>
-      <p:sp>
-        <p:nvSpPr>
-          <p:cNvPr id="6" name="Text 4"/>
-          <p:cNvSpPr/>
-          <p:nvPr/>
-        </p:nvSpPr>
-        <p:spPr>
-          <a:xfrm>
-            <a:off x="548640" y="3383280"/>
-            <a:ext cx="11091672" cy="1005840"/>
+            <a:endParaRPr lang="en-US" sz="2000" dirty="0"/>
+          </a:p>
+        </p:txBody>
+      </p:sp>
+      <p:sp>
+        <p:nvSpPr>
+          <p:cNvPr id="6" name="Shape 4"/>
+          <p:cNvSpPr/>
+          <p:nvPr/>
+        </p:nvSpPr>
+        <p:spPr>
+          <a:xfrm>
+            <a:off x="548640" y="2606040"/>
+            <a:ext cx="5408676" cy="1920240"/>
+          </a:xfrm>
+          <a:prstGeom prst="roundRect">
+            <a:avLst/>
+          </a:prstGeom>
+          <a:solidFill>
+            <a:srgbClr val="FBEAEA"/>
+          </a:solidFill>
+          <a:ln w="19050">
+            <a:solidFill>
+              <a:srgbClr val="C62828"/>
+            </a:solidFill>
+            <a:prstDash val="solid"/>
+          </a:ln>
+        </p:spPr>
+        <p:txBody>
+          <a:bodyPr/>
+          <a:lstStyle/>
+          <a:p>
+            <a:endParaRPr lang="es-ES"/>
+          </a:p>
+        </p:txBody>
+      </p:sp>
+      <p:sp>
+        <p:nvSpPr>
+          <p:cNvPr id="7" name="Shape 5"/>
+          <p:cNvSpPr/>
+          <p:nvPr/>
+        </p:nvSpPr>
+        <p:spPr>
+          <a:xfrm>
+            <a:off x="777240" y="2734056"/>
+            <a:ext cx="73152" cy="384048"/>
+          </a:xfrm>
+          <a:prstGeom prst="rect">
+            <a:avLst/>
+          </a:prstGeom>
+          <a:solidFill>
+            <a:srgbClr val="E64A19"/>
+          </a:solidFill>
+          <a:ln w="12700">
+            <a:solidFill>
+              <a:srgbClr val="E64A19"/>
+            </a:solidFill>
+            <a:prstDash val="solid"/>
+          </a:ln>
+        </p:spPr>
+        <p:txBody>
+          <a:bodyPr/>
+          <a:lstStyle/>
+          <a:p>
+            <a:endParaRPr lang="es-ES"/>
+          </a:p>
+        </p:txBody>
+      </p:sp>
+      <p:sp>
+        <p:nvSpPr>
+          <p:cNvPr id="8" name="Text 6"/>
+          <p:cNvSpPr/>
+          <p:nvPr/>
+        </p:nvSpPr>
+        <p:spPr>
+          <a:xfrm>
+            <a:off x="960120" y="2697480"/>
+            <a:ext cx="4814316" cy="457200"/>
           </a:xfrm>
           <a:prstGeom prst="rect">
             <a:avLst/>
@@ -2005,14 +1573,53 @@
           <a:ln/>
         </p:spPr>
         <p:txBody>
-          <a:bodyPr wrap="square" rtlCol="0" anchor="t"/>
+          <a:bodyPr wrap="square" rtlCol="0" anchor="ctr"/>
           <a:lstStyle/>
           <a:p>
             <a:pPr marL="0" indent="0">
               <a:buNone/>
             </a:pPr>
             <a:r>
-              <a:rPr lang="en-US" sz="2200" dirty="0">
+              <a:rPr lang="en-US" sz="2200" b="1" dirty="0">
+                <a:solidFill>
+                  <a:srgbClr val="7F0000"/>
+                </a:solidFill>
+                <a:latin typeface="Arial" pitchFamily="34" charset="0"/>
+                <a:ea typeface="Arial" pitchFamily="34" charset="-122"/>
+                <a:cs typeface="Arial" pitchFamily="34" charset="-120"/>
+              </a:rPr>
+              <a:t>Hasta ahora, con Docker</a:t>
+            </a:r>
+            <a:endParaRPr lang="en-US" sz="2200" dirty="0"/>
+          </a:p>
+        </p:txBody>
+      </p:sp>
+      <p:sp>
+        <p:nvSpPr>
+          <p:cNvPr id="9" name="Text 7"/>
+          <p:cNvSpPr/>
+          <p:nvPr/>
+        </p:nvSpPr>
+        <p:spPr>
+          <a:xfrm>
+            <a:off x="822960" y="3227832"/>
+            <a:ext cx="4860036" cy="1188720"/>
+          </a:xfrm>
+          <a:prstGeom prst="rect">
+            <a:avLst/>
+          </a:prstGeom>
+          <a:noFill/>
+          <a:ln/>
+        </p:spPr>
+        <p:txBody>
+          <a:bodyPr wrap="square" rtlCol="0" anchor="t"/>
+          <a:lstStyle/>
+          <a:p>
+            <a:pPr marL="0" indent="0">
+              <a:buNone/>
+            </a:pPr>
+            <a:r>
+              <a:rPr lang="en-US" sz="1800" dirty="0">
                 <a:solidFill>
                   <a:srgbClr val="212121"/>
                 </a:solidFill>
@@ -2020,7 +1627,110 @@
                 <a:ea typeface="Arial" pitchFamily="34" charset="-122"/>
                 <a:cs typeface="Arial" pitchFamily="34" charset="-120"/>
               </a:rPr>
-              <a:t>Hasta ahora has usado Docker para meter un servicio dentro de un contenedor, como una base de datos.</a:t>
+              <a:t>Metías un servicio dentro de un contenedor, como una base de datos, y tu aplicación se conectaba a él.</a:t>
+            </a:r>
+            <a:endParaRPr lang="en-US" sz="1800" dirty="0"/>
+          </a:p>
+        </p:txBody>
+      </p:sp>
+      <p:sp>
+        <p:nvSpPr>
+          <p:cNvPr id="10" name="Shape 8"/>
+          <p:cNvSpPr/>
+          <p:nvPr/>
+        </p:nvSpPr>
+        <p:spPr>
+          <a:xfrm>
+            <a:off x="6231636" y="2606040"/>
+            <a:ext cx="5408676" cy="1920240"/>
+          </a:xfrm>
+          <a:prstGeom prst="roundRect">
+            <a:avLst/>
+          </a:prstGeom>
+          <a:solidFill>
+            <a:srgbClr val="FBEAEA"/>
+          </a:solidFill>
+          <a:ln w="19050">
+            <a:solidFill>
+              <a:srgbClr val="C62828"/>
+            </a:solidFill>
+            <a:prstDash val="solid"/>
+          </a:ln>
+        </p:spPr>
+        <p:txBody>
+          <a:bodyPr/>
+          <a:lstStyle/>
+          <a:p>
+            <a:endParaRPr lang="es-ES"/>
+          </a:p>
+        </p:txBody>
+      </p:sp>
+      <p:sp>
+        <p:nvSpPr>
+          <p:cNvPr id="11" name="Shape 9"/>
+          <p:cNvSpPr/>
+          <p:nvPr/>
+        </p:nvSpPr>
+        <p:spPr>
+          <a:xfrm>
+            <a:off x="6460236" y="2734056"/>
+            <a:ext cx="73152" cy="384048"/>
+          </a:xfrm>
+          <a:prstGeom prst="rect">
+            <a:avLst/>
+          </a:prstGeom>
+          <a:solidFill>
+            <a:srgbClr val="E64A19"/>
+          </a:solidFill>
+          <a:ln w="12700">
+            <a:solidFill>
+              <a:srgbClr val="E64A19"/>
+            </a:solidFill>
+            <a:prstDash val="solid"/>
+          </a:ln>
+        </p:spPr>
+        <p:txBody>
+          <a:bodyPr/>
+          <a:lstStyle/>
+          <a:p>
+            <a:endParaRPr lang="es-ES"/>
+          </a:p>
+        </p:txBody>
+      </p:sp>
+      <p:sp>
+        <p:nvSpPr>
+          <p:cNvPr id="12" name="Text 10"/>
+          <p:cNvSpPr/>
+          <p:nvPr/>
+        </p:nvSpPr>
+        <p:spPr>
+          <a:xfrm>
+            <a:off x="6643116" y="2697480"/>
+            <a:ext cx="4814316" cy="457200"/>
+          </a:xfrm>
+          <a:prstGeom prst="rect">
+            <a:avLst/>
+          </a:prstGeom>
+          <a:noFill/>
+          <a:ln/>
+        </p:spPr>
+        <p:txBody>
+          <a:bodyPr wrap="square" rtlCol="0" anchor="ctr"/>
+          <a:lstStyle/>
+          <a:p>
+            <a:pPr marL="0" indent="0">
+              <a:buNone/>
+            </a:pPr>
+            <a:r>
+              <a:rPr lang="en-US" sz="2200" b="1" dirty="0">
+                <a:solidFill>
+                  <a:srgbClr val="7F0000"/>
+                </a:solidFill>
+                <a:latin typeface="Arial" pitchFamily="34" charset="0"/>
+                <a:ea typeface="Arial" pitchFamily="34" charset="-122"/>
+                <a:cs typeface="Arial" pitchFamily="34" charset="-120"/>
+              </a:rPr>
+              <a:t>Con un Dev Container</a:t>
             </a:r>
             <a:endParaRPr lang="en-US" sz="2200" dirty="0"/>
           </a:p>
@@ -2028,14 +1738,53 @@
       </p:sp>
       <p:sp>
         <p:nvSpPr>
-          <p:cNvPr id="7" name="Shape 5"/>
-          <p:cNvSpPr/>
-          <p:nvPr/>
-        </p:nvSpPr>
-        <p:spPr>
-          <a:xfrm>
-            <a:off x="548640" y="4800600"/>
-            <a:ext cx="11091672" cy="1280160"/>
+          <p:cNvPr id="13" name="Text 11"/>
+          <p:cNvSpPr/>
+          <p:nvPr/>
+        </p:nvSpPr>
+        <p:spPr>
+          <a:xfrm>
+            <a:off x="6505956" y="3227832"/>
+            <a:ext cx="4860036" cy="1188720"/>
+          </a:xfrm>
+          <a:prstGeom prst="rect">
+            <a:avLst/>
+          </a:prstGeom>
+          <a:noFill/>
+          <a:ln/>
+        </p:spPr>
+        <p:txBody>
+          <a:bodyPr wrap="square" rtlCol="0" anchor="t"/>
+          <a:lstStyle/>
+          <a:p>
+            <a:pPr marL="0" indent="0">
+              <a:buNone/>
+            </a:pPr>
+            <a:r>
+              <a:rPr lang="en-US" sz="1800" dirty="0">
+                <a:solidFill>
+                  <a:srgbClr val="212121"/>
+                </a:solidFill>
+                <a:latin typeface="Arial" pitchFamily="34" charset="0"/>
+                <a:ea typeface="Arial" pitchFamily="34" charset="-122"/>
+                <a:cs typeface="Arial" pitchFamily="34" charset="-120"/>
+              </a:rPr>
+              <a:t>Metes dentro tu propio entorno de programación, y tu editor se conecta ahí para trabajar como si fuera tu ordenador.</a:t>
+            </a:r>
+            <a:endParaRPr lang="en-US" sz="1800" dirty="0"/>
+          </a:p>
+        </p:txBody>
+      </p:sp>
+      <p:sp>
+        <p:nvSpPr>
+          <p:cNvPr id="14" name="Shape 12"/>
+          <p:cNvSpPr/>
+          <p:nvPr/>
+        </p:nvSpPr>
+        <p:spPr>
+          <a:xfrm>
+            <a:off x="548640" y="4846320"/>
+            <a:ext cx="11091672" cy="914400"/>
           </a:xfrm>
           <a:prstGeom prst="roundRect">
             <a:avLst/>
@@ -2060,14 +1809,14 @@
       </p:sp>
       <p:sp>
         <p:nvSpPr>
-          <p:cNvPr id="8" name="Text 6"/>
-          <p:cNvSpPr/>
-          <p:nvPr/>
-        </p:nvSpPr>
-        <p:spPr>
-          <a:xfrm>
-            <a:off x="822960" y="4892040"/>
-            <a:ext cx="10543032" cy="1097280"/>
+          <p:cNvPr id="15" name="Text 13"/>
+          <p:cNvSpPr/>
+          <p:nvPr/>
+        </p:nvSpPr>
+        <p:spPr>
+          <a:xfrm>
+            <a:off x="822960" y="4937760"/>
+            <a:ext cx="10543032" cy="731520"/>
           </a:xfrm>
           <a:prstGeom prst="rect">
             <a:avLst/>
@@ -2091,7 +1840,7 @@
                 <a:ea typeface="Arial" pitchFamily="34" charset="-122"/>
                 <a:cs typeface="Arial" pitchFamily="34" charset="-120"/>
               </a:rPr>
-              <a:t>Un Dev Container aplica la misma idea a otra cosa: mete dentro del contenedor tu propio entorno de programación, y tu editor se conecta ahí para trabajar como si ese contenedor fuera tu ordenador.</a:t>
+              <a:t>La misma idea que ya conoces de Docker, aplicada a tu entorno de trabajo.</a:t>
             </a:r>
             <a:endParaRPr lang="en-US" sz="2100" dirty="0"/>
           </a:p>
@@ -2240,8 +1989,8 @@
         </p:nvSpPr>
         <p:spPr>
           <a:xfrm>
-            <a:off x="548640" y="1640322"/>
-            <a:ext cx="11091672" cy="2743200"/>
+            <a:off x="548640" y="1005840"/>
+            <a:ext cx="11091672" cy="1097280"/>
           </a:xfrm>
           <a:prstGeom prst="rect">
             <a:avLst/>
@@ -2257,7 +2006,7 @@
               <a:buNone/>
             </a:pPr>
             <a:r>
-              <a:rPr lang="en-US" sz="2200" dirty="0">
+              <a:rPr lang="en-US" sz="2000" dirty="0">
                 <a:solidFill>
                   <a:srgbClr val="212121"/>
                 </a:solidFill>
@@ -2265,83 +2014,37 @@
                 <a:ea typeface="Arial" pitchFamily="34" charset="-122"/>
                 <a:cs typeface="Arial" pitchFamily="34" charset="-120"/>
               </a:rPr>
-              <a:t>“¿Cómo que mi editor está dentro de un contenedor, si lo sigo viendo en mi propia pantalla?” La clave está en separar dos cosas: la ventana que ves (menús, pestañas, el propio VS Code) se queda en tu ordenador, igual que siempre. Pero todo lo que hace falta para trabajar de verdad —terminal, comandos, compilador, extensiones— corre dentro del contenedor.</a:t>
+              <a:t>“¿Cómo que mi editor está dentro de un contenedor, si lo sigo viendo en mi propia pantalla?” La ventana se queda en tu ordenador; el trabajo de verdad corre dentro del contenedor.</a:t>
             </a:r>
-            <a:endParaRPr lang="en-US" sz="2200" dirty="0"/>
-          </a:p>
-        </p:txBody>
-      </p:sp>
-      <p:sp>
-        <p:nvSpPr>
-          <p:cNvPr id="6" name="Shape 4"/>
-          <p:cNvSpPr/>
-          <p:nvPr/>
-        </p:nvSpPr>
-        <p:spPr>
-          <a:xfrm>
-            <a:off x="548640" y="4206240"/>
-            <a:ext cx="11091672" cy="1280160"/>
-          </a:xfrm>
-          <a:prstGeom prst="roundRect">
-            <a:avLst/>
-          </a:prstGeom>
-          <a:solidFill>
-            <a:srgbClr val="FBE9E7"/>
-          </a:solidFill>
-          <a:ln w="19050">
-            <a:solidFill>
-              <a:srgbClr val="E64A19"/>
-            </a:solidFill>
-            <a:prstDash val="solid"/>
-          </a:ln>
-        </p:spPr>
-        <p:txBody>
-          <a:bodyPr/>
-          <a:lstStyle/>
-          <a:p>
-            <a:endParaRPr lang="es-ES"/>
-          </a:p>
-        </p:txBody>
-      </p:sp>
-      <p:sp>
-        <p:nvSpPr>
-          <p:cNvPr id="7" name="Text 5"/>
-          <p:cNvSpPr/>
-          <p:nvPr/>
-        </p:nvSpPr>
-        <p:spPr>
-          <a:xfrm>
-            <a:off x="822960" y="4297680"/>
-            <a:ext cx="10543032" cy="1097280"/>
+            <a:endParaRPr lang="en-US" sz="2000" dirty="0"/>
+          </a:p>
+        </p:txBody>
+      </p:sp>
+      <p:pic>
+        <p:nvPicPr>
+          <p:cNvPr id="6" name="Image 0" descr="C:/Users/Aitor/Documents/apuntes-profe/acceso-a-datos/docs/tema0/img/devcontainers/devcontainer_dos_mitades.png"/>
+          <p:cNvPicPr>
+            <a:picLocks noChangeAspect="1"/>
+          </p:cNvPicPr>
+          <p:nvPr/>
+        </p:nvPicPr>
+        <p:blipFill>
+          <a:blip r:embed="rId3"/>
+          <a:srcRect t="4807" b="4477"/>
+          <a:stretch>
+            <a:fillRect/>
+          </a:stretch>
+        </p:blipFill>
+        <p:spPr>
+          <a:xfrm>
+            <a:off x="1571830" y="1791477"/>
+            <a:ext cx="8877341" cy="4542515"/>
           </a:xfrm>
           <a:prstGeom prst="rect">
             <a:avLst/>
           </a:prstGeom>
-          <a:noFill/>
-          <a:ln/>
-        </p:spPr>
-        <p:txBody>
-          <a:bodyPr wrap="square" rtlCol="0" anchor="ctr"/>
-          <a:lstStyle/>
-          <a:p>
-            <a:pPr marL="0" indent="0">
-              <a:buNone/>
-            </a:pPr>
-            <a:r>
-              <a:rPr lang="en-US" sz="2100" dirty="0">
-                <a:solidFill>
-                  <a:srgbClr val="212121"/>
-                </a:solidFill>
-                <a:latin typeface="Arial" pitchFamily="34" charset="0"/>
-                <a:ea typeface="Arial" pitchFamily="34" charset="-122"/>
-                <a:cs typeface="Arial" pitchFamily="34" charset="-120"/>
-              </a:rPr>
-              <a:t>Como un escritorio remoto: la pantalla, el ratón y el teclado son tuyos, pero el trabajo de verdad ocurre en la máquina remota. Aquí, la "máquina remota" es un contenedor Docker en tu propio ordenador.</a:t>
-            </a:r>
-            <a:endParaRPr lang="en-US" sz="2100" dirty="0"/>
-          </a:p>
-        </p:txBody>
-      </p:sp>
+        </p:spPr>
+      </p:pic>
     </p:spTree>
   </p:cSld>
   <p:clrMapOvr>
@@ -2446,7 +2149,7 @@
         </p:nvSpPr>
         <p:spPr>
           <a:xfrm>
-            <a:off x="548640" y="6473952"/>
+            <a:off x="548640" y="6414982"/>
             <a:ext cx="11091672" cy="292608"/>
           </a:xfrm>
           <a:prstGeom prst="rect">
@@ -2477,675 +2180,31 @@
           </a:p>
         </p:txBody>
       </p:sp>
-      <p:sp>
-        <p:nvSpPr>
-          <p:cNvPr id="5" name="Shape 3"/>
-          <p:cNvSpPr/>
-          <p:nvPr/>
-        </p:nvSpPr>
-        <p:spPr>
-          <a:xfrm>
-            <a:off x="548640" y="1800808"/>
-            <a:ext cx="1998878" cy="2194560"/>
-          </a:xfrm>
-          <a:prstGeom prst="roundRect">
-            <a:avLst/>
-          </a:prstGeom>
-          <a:solidFill>
-            <a:srgbClr val="FBEAEA"/>
-          </a:solidFill>
-          <a:ln w="15875">
-            <a:solidFill>
-              <a:srgbClr val="C62828"/>
-            </a:solidFill>
-            <a:prstDash val="solid"/>
-          </a:ln>
-        </p:spPr>
-        <p:txBody>
-          <a:bodyPr/>
-          <a:lstStyle/>
-          <a:p>
-            <a:endParaRPr lang="es-ES"/>
-          </a:p>
-        </p:txBody>
-      </p:sp>
-      <p:sp>
-        <p:nvSpPr>
-          <p:cNvPr id="6" name="Text 4"/>
-          <p:cNvSpPr/>
-          <p:nvPr/>
-        </p:nvSpPr>
-        <p:spPr>
-          <a:xfrm>
-            <a:off x="594360" y="1846528"/>
-            <a:ext cx="1907438" cy="2103120"/>
+      <p:pic>
+        <p:nvPicPr>
+          <p:cNvPr id="5" name="Image 0" descr="C:/Users/Aitor/Documents/apuntes-profe/acceso-a-datos/docs/tema0/img/devcontainers/devcontainer_flujo_pasos.png"/>
+          <p:cNvPicPr>
+            <a:picLocks noChangeAspect="1"/>
+          </p:cNvPicPr>
+          <p:nvPr/>
+        </p:nvPicPr>
+        <p:blipFill>
+          <a:blip r:embed="rId3"/>
+          <a:srcRect t="4913" b="10078"/>
+          <a:stretch>
+            <a:fillRect/>
+          </a:stretch>
+        </p:blipFill>
+        <p:spPr>
+          <a:xfrm>
+            <a:off x="818196" y="1024035"/>
+            <a:ext cx="10784824" cy="5171492"/>
           </a:xfrm>
           <a:prstGeom prst="rect">
             <a:avLst/>
           </a:prstGeom>
-          <a:noFill/>
-          <a:ln/>
-        </p:spPr>
-        <p:txBody>
-          <a:bodyPr wrap="square" rtlCol="0" anchor="ctr"/>
-          <a:lstStyle/>
-          <a:p>
-            <a:pPr marL="0" indent="0" algn="ctr">
-              <a:buNone/>
-            </a:pPr>
-            <a:r>
-              <a:rPr lang="en-US" sz="1800" dirty="0">
-                <a:solidFill>
-                  <a:srgbClr val="212121"/>
-                </a:solidFill>
-                <a:latin typeface="Arial" pitchFamily="34" charset="0"/>
-                <a:ea typeface="Arial" pitchFamily="34" charset="-122"/>
-                <a:cs typeface="Arial" pitchFamily="34" charset="-120"/>
-              </a:rPr>
-              <a:t>Abres el proyecto</a:t>
-            </a:r>
-            <a:endParaRPr lang="en-US" sz="1800" dirty="0"/>
-          </a:p>
-          <a:p>
-            <a:pPr marL="0" indent="0" algn="ctr">
-              <a:buNone/>
-            </a:pPr>
-            <a:r>
-              <a:rPr lang="en-US" sz="1800" dirty="0">
-                <a:solidFill>
-                  <a:srgbClr val="212121"/>
-                </a:solidFill>
-                <a:latin typeface="Arial" pitchFamily="34" charset="0"/>
-                <a:ea typeface="Arial" pitchFamily="34" charset="-122"/>
-                <a:cs typeface="Arial" pitchFamily="34" charset="-120"/>
-              </a:rPr>
-              <a:t>en VS Code</a:t>
-            </a:r>
-            <a:endParaRPr lang="en-US" sz="1800" dirty="0"/>
-          </a:p>
-        </p:txBody>
-      </p:sp>
-      <p:sp>
-        <p:nvSpPr>
-          <p:cNvPr id="7" name="Text 5"/>
-          <p:cNvSpPr/>
-          <p:nvPr/>
-        </p:nvSpPr>
-        <p:spPr>
-          <a:xfrm>
-            <a:off x="2529230" y="1800808"/>
-            <a:ext cx="310896" cy="2194560"/>
-          </a:xfrm>
-          <a:prstGeom prst="rect">
-            <a:avLst/>
-          </a:prstGeom>
-          <a:noFill/>
-          <a:ln/>
-        </p:spPr>
-        <p:txBody>
-          <a:bodyPr wrap="square" rtlCol="0" anchor="ctr"/>
-          <a:lstStyle/>
-          <a:p>
-            <a:pPr marL="0" indent="0" algn="ctr">
-              <a:buNone/>
-            </a:pPr>
-            <a:r>
-              <a:rPr lang="en-US" sz="2000" b="1" dirty="0">
-                <a:solidFill>
-                  <a:srgbClr val="C62828"/>
-                </a:solidFill>
-                <a:latin typeface="Arial" pitchFamily="34" charset="0"/>
-                <a:ea typeface="Arial" pitchFamily="34" charset="-122"/>
-                <a:cs typeface="Arial" pitchFamily="34" charset="-120"/>
-              </a:rPr>
-              <a:t>→</a:t>
-            </a:r>
-            <a:endParaRPr lang="en-US" sz="2000" dirty="0"/>
-          </a:p>
-        </p:txBody>
-      </p:sp>
-      <p:sp>
-        <p:nvSpPr>
-          <p:cNvPr id="8" name="Shape 6"/>
-          <p:cNvSpPr/>
-          <p:nvPr/>
-        </p:nvSpPr>
-        <p:spPr>
-          <a:xfrm>
-            <a:off x="2821838" y="1800808"/>
-            <a:ext cx="1998878" cy="2194560"/>
-          </a:xfrm>
-          <a:prstGeom prst="roundRect">
-            <a:avLst/>
-          </a:prstGeom>
-          <a:solidFill>
-            <a:srgbClr val="FBEAEA"/>
-          </a:solidFill>
-          <a:ln w="15875">
-            <a:solidFill>
-              <a:srgbClr val="C62828"/>
-            </a:solidFill>
-            <a:prstDash val="solid"/>
-          </a:ln>
-        </p:spPr>
-        <p:txBody>
-          <a:bodyPr/>
-          <a:lstStyle/>
-          <a:p>
-            <a:endParaRPr lang="es-ES"/>
-          </a:p>
-        </p:txBody>
-      </p:sp>
-      <p:sp>
-        <p:nvSpPr>
-          <p:cNvPr id="9" name="Text 7"/>
-          <p:cNvSpPr/>
-          <p:nvPr/>
-        </p:nvSpPr>
-        <p:spPr>
-          <a:xfrm>
-            <a:off x="2867558" y="1846528"/>
-            <a:ext cx="1907438" cy="2103120"/>
-          </a:xfrm>
-          <a:prstGeom prst="rect">
-            <a:avLst/>
-          </a:prstGeom>
-          <a:noFill/>
-          <a:ln/>
-        </p:spPr>
-        <p:txBody>
-          <a:bodyPr wrap="square" rtlCol="0" anchor="ctr"/>
-          <a:lstStyle/>
-          <a:p>
-            <a:pPr marL="0" indent="0" algn="ctr">
-              <a:buNone/>
-            </a:pPr>
-            <a:r>
-              <a:rPr lang="en-US" sz="1800" dirty="0">
-                <a:solidFill>
-                  <a:srgbClr val="212121"/>
-                </a:solidFill>
-                <a:latin typeface="Arial" pitchFamily="34" charset="0"/>
-                <a:ea typeface="Arial" pitchFamily="34" charset="-122"/>
-                <a:cs typeface="Arial" pitchFamily="34" charset="-120"/>
-              </a:rPr>
-              <a:t>¿Existe</a:t>
-            </a:r>
-            <a:endParaRPr lang="en-US" sz="1800" dirty="0"/>
-          </a:p>
-          <a:p>
-            <a:pPr marL="0" indent="0" algn="ctr">
-              <a:buNone/>
-            </a:pPr>
-            <a:r>
-              <a:rPr lang="en-US" sz="1800" dirty="0">
-                <a:solidFill>
-                  <a:srgbClr val="212121"/>
-                </a:solidFill>
-                <a:latin typeface="Arial" pitchFamily="34" charset="0"/>
-                <a:ea typeface="Arial" pitchFamily="34" charset="-122"/>
-                <a:cs typeface="Arial" pitchFamily="34" charset="-120"/>
-              </a:rPr>
-              <a:t>devcontainer.json?</a:t>
-            </a:r>
-            <a:endParaRPr lang="en-US" sz="1800" dirty="0"/>
-          </a:p>
-        </p:txBody>
-      </p:sp>
-      <p:sp>
-        <p:nvSpPr>
-          <p:cNvPr id="10" name="Text 8"/>
-          <p:cNvSpPr/>
-          <p:nvPr/>
-        </p:nvSpPr>
-        <p:spPr>
-          <a:xfrm>
-            <a:off x="4802429" y="1800808"/>
-            <a:ext cx="310896" cy="2194560"/>
-          </a:xfrm>
-          <a:prstGeom prst="rect">
-            <a:avLst/>
-          </a:prstGeom>
-          <a:noFill/>
-          <a:ln/>
-        </p:spPr>
-        <p:txBody>
-          <a:bodyPr wrap="square" rtlCol="0" anchor="ctr"/>
-          <a:lstStyle/>
-          <a:p>
-            <a:pPr marL="0" indent="0" algn="ctr">
-              <a:buNone/>
-            </a:pPr>
-            <a:r>
-              <a:rPr lang="en-US" sz="2000" b="1" dirty="0">
-                <a:solidFill>
-                  <a:srgbClr val="C62828"/>
-                </a:solidFill>
-                <a:latin typeface="Arial" pitchFamily="34" charset="0"/>
-                <a:ea typeface="Arial" pitchFamily="34" charset="-122"/>
-                <a:cs typeface="Arial" pitchFamily="34" charset="-120"/>
-              </a:rPr>
-              <a:t>→</a:t>
-            </a:r>
-            <a:endParaRPr lang="en-US" sz="2000" dirty="0"/>
-          </a:p>
-        </p:txBody>
-      </p:sp>
-      <p:sp>
-        <p:nvSpPr>
-          <p:cNvPr id="11" name="Shape 9"/>
-          <p:cNvSpPr/>
-          <p:nvPr/>
-        </p:nvSpPr>
-        <p:spPr>
-          <a:xfrm>
-            <a:off x="5095037" y="1800808"/>
-            <a:ext cx="1998878" cy="2194560"/>
-          </a:xfrm>
-          <a:prstGeom prst="roundRect">
-            <a:avLst/>
-          </a:prstGeom>
-          <a:solidFill>
-            <a:srgbClr val="FBEAEA"/>
-          </a:solidFill>
-          <a:ln w="15875">
-            <a:solidFill>
-              <a:srgbClr val="C62828"/>
-            </a:solidFill>
-            <a:prstDash val="solid"/>
-          </a:ln>
-        </p:spPr>
-        <p:txBody>
-          <a:bodyPr/>
-          <a:lstStyle/>
-          <a:p>
-            <a:endParaRPr lang="es-ES"/>
-          </a:p>
-        </p:txBody>
-      </p:sp>
-      <p:sp>
-        <p:nvSpPr>
-          <p:cNvPr id="12" name="Text 10"/>
-          <p:cNvSpPr/>
-          <p:nvPr/>
-        </p:nvSpPr>
-        <p:spPr>
-          <a:xfrm>
-            <a:off x="5140757" y="1846528"/>
-            <a:ext cx="1907438" cy="2103120"/>
-          </a:xfrm>
-          <a:prstGeom prst="rect">
-            <a:avLst/>
-          </a:prstGeom>
-          <a:noFill/>
-          <a:ln/>
-        </p:spPr>
-        <p:txBody>
-          <a:bodyPr wrap="square" rtlCol="0" anchor="ctr"/>
-          <a:lstStyle/>
-          <a:p>
-            <a:pPr marL="0" indent="0" algn="ctr">
-              <a:buNone/>
-            </a:pPr>
-            <a:r>
-              <a:rPr lang="en-US" sz="1800" dirty="0">
-                <a:solidFill>
-                  <a:srgbClr val="212121"/>
-                </a:solidFill>
-                <a:latin typeface="Arial" pitchFamily="34" charset="0"/>
-                <a:ea typeface="Arial" pitchFamily="34" charset="-122"/>
-                <a:cs typeface="Arial" pitchFamily="34" charset="-120"/>
-              </a:rPr>
-              <a:t>"Reopen in</a:t>
-            </a:r>
-            <a:endParaRPr lang="en-US" sz="1800" dirty="0"/>
-          </a:p>
-          <a:p>
-            <a:pPr marL="0" indent="0" algn="ctr">
-              <a:buNone/>
-            </a:pPr>
-            <a:r>
-              <a:rPr lang="en-US" sz="1800" dirty="0">
-                <a:solidFill>
-                  <a:srgbClr val="212121"/>
-                </a:solidFill>
-                <a:latin typeface="Arial" pitchFamily="34" charset="0"/>
-                <a:ea typeface="Arial" pitchFamily="34" charset="-122"/>
-                <a:cs typeface="Arial" pitchFamily="34" charset="-120"/>
-              </a:rPr>
-              <a:t>Container"</a:t>
-            </a:r>
-            <a:endParaRPr lang="en-US" sz="1800" dirty="0"/>
-          </a:p>
-        </p:txBody>
-      </p:sp>
-      <p:sp>
-        <p:nvSpPr>
-          <p:cNvPr id="13" name="Text 11"/>
-          <p:cNvSpPr/>
-          <p:nvPr/>
-        </p:nvSpPr>
-        <p:spPr>
-          <a:xfrm>
-            <a:off x="7075627" y="1800808"/>
-            <a:ext cx="310896" cy="2194560"/>
-          </a:xfrm>
-          <a:prstGeom prst="rect">
-            <a:avLst/>
-          </a:prstGeom>
-          <a:noFill/>
-          <a:ln/>
-        </p:spPr>
-        <p:txBody>
-          <a:bodyPr wrap="square" rtlCol="0" anchor="ctr"/>
-          <a:lstStyle/>
-          <a:p>
-            <a:pPr marL="0" indent="0" algn="ctr">
-              <a:buNone/>
-            </a:pPr>
-            <a:r>
-              <a:rPr lang="en-US" sz="2000" b="1" dirty="0">
-                <a:solidFill>
-                  <a:srgbClr val="C62828"/>
-                </a:solidFill>
-                <a:latin typeface="Arial" pitchFamily="34" charset="0"/>
-                <a:ea typeface="Arial" pitchFamily="34" charset="-122"/>
-                <a:cs typeface="Arial" pitchFamily="34" charset="-120"/>
-              </a:rPr>
-              <a:t>→</a:t>
-            </a:r>
-            <a:endParaRPr lang="en-US" sz="2000" dirty="0"/>
-          </a:p>
-        </p:txBody>
-      </p:sp>
-      <p:sp>
-        <p:nvSpPr>
-          <p:cNvPr id="14" name="Shape 12"/>
-          <p:cNvSpPr/>
-          <p:nvPr/>
-        </p:nvSpPr>
-        <p:spPr>
-          <a:xfrm>
-            <a:off x="7368235" y="1800808"/>
-            <a:ext cx="1998878" cy="2194560"/>
-          </a:xfrm>
-          <a:prstGeom prst="roundRect">
-            <a:avLst/>
-          </a:prstGeom>
-          <a:solidFill>
-            <a:srgbClr val="FBEAEA"/>
-          </a:solidFill>
-          <a:ln w="15875">
-            <a:solidFill>
-              <a:srgbClr val="C62828"/>
-            </a:solidFill>
-            <a:prstDash val="solid"/>
-          </a:ln>
-        </p:spPr>
-        <p:txBody>
-          <a:bodyPr/>
-          <a:lstStyle/>
-          <a:p>
-            <a:endParaRPr lang="es-ES"/>
-          </a:p>
-        </p:txBody>
-      </p:sp>
-      <p:sp>
-        <p:nvSpPr>
-          <p:cNvPr id="15" name="Text 13"/>
-          <p:cNvSpPr/>
-          <p:nvPr/>
-        </p:nvSpPr>
-        <p:spPr>
-          <a:xfrm>
-            <a:off x="7413955" y="1846528"/>
-            <a:ext cx="1907438" cy="2103120"/>
-          </a:xfrm>
-          <a:prstGeom prst="rect">
-            <a:avLst/>
-          </a:prstGeom>
-          <a:noFill/>
-          <a:ln/>
-        </p:spPr>
-        <p:txBody>
-          <a:bodyPr wrap="square" rtlCol="0" anchor="ctr"/>
-          <a:lstStyle/>
-          <a:p>
-            <a:pPr marL="0" indent="0" algn="ctr">
-              <a:buNone/>
-            </a:pPr>
-            <a:r>
-              <a:rPr lang="en-US" sz="1800" dirty="0">
-                <a:solidFill>
-                  <a:srgbClr val="212121"/>
-                </a:solidFill>
-                <a:latin typeface="Arial" pitchFamily="34" charset="0"/>
-                <a:ea typeface="Arial" pitchFamily="34" charset="-122"/>
-                <a:cs typeface="Arial" pitchFamily="34" charset="-120"/>
-              </a:rPr>
-              <a:t>Docker crea el</a:t>
-            </a:r>
-            <a:endParaRPr lang="en-US" sz="1800" dirty="0"/>
-          </a:p>
-          <a:p>
-            <a:pPr marL="0" indent="0" algn="ctr">
-              <a:buNone/>
-            </a:pPr>
-            <a:r>
-              <a:rPr lang="en-US" sz="1800" dirty="0">
-                <a:solidFill>
-                  <a:srgbClr val="212121"/>
-                </a:solidFill>
-                <a:latin typeface="Arial" pitchFamily="34" charset="0"/>
-                <a:ea typeface="Arial" pitchFamily="34" charset="-122"/>
-                <a:cs typeface="Arial" pitchFamily="34" charset="-120"/>
-              </a:rPr>
-              <a:t>contenedor y monta</a:t>
-            </a:r>
-            <a:endParaRPr lang="en-US" sz="1800" dirty="0"/>
-          </a:p>
-          <a:p>
-            <a:pPr marL="0" indent="0" algn="ctr">
-              <a:buNone/>
-            </a:pPr>
-            <a:r>
-              <a:rPr lang="en-US" sz="1800" dirty="0">
-                <a:solidFill>
-                  <a:srgbClr val="212121"/>
-                </a:solidFill>
-                <a:latin typeface="Arial" pitchFamily="34" charset="0"/>
-                <a:ea typeface="Arial" pitchFamily="34" charset="-122"/>
-                <a:cs typeface="Arial" pitchFamily="34" charset="-120"/>
-              </a:rPr>
-              <a:t>tu carpeta</a:t>
-            </a:r>
-            <a:endParaRPr lang="en-US" sz="1800" dirty="0"/>
-          </a:p>
-        </p:txBody>
-      </p:sp>
-      <p:sp>
-        <p:nvSpPr>
-          <p:cNvPr id="16" name="Text 14"/>
-          <p:cNvSpPr/>
-          <p:nvPr/>
-        </p:nvSpPr>
-        <p:spPr>
-          <a:xfrm>
-            <a:off x="9348826" y="1800808"/>
-            <a:ext cx="310896" cy="2194560"/>
-          </a:xfrm>
-          <a:prstGeom prst="rect">
-            <a:avLst/>
-          </a:prstGeom>
-          <a:noFill/>
-          <a:ln/>
-        </p:spPr>
-        <p:txBody>
-          <a:bodyPr wrap="square" rtlCol="0" anchor="ctr"/>
-          <a:lstStyle/>
-          <a:p>
-            <a:pPr marL="0" indent="0" algn="ctr">
-              <a:buNone/>
-            </a:pPr>
-            <a:r>
-              <a:rPr lang="en-US" sz="2000" b="1" dirty="0">
-                <a:solidFill>
-                  <a:srgbClr val="C62828"/>
-                </a:solidFill>
-                <a:latin typeface="Arial" pitchFamily="34" charset="0"/>
-                <a:ea typeface="Arial" pitchFamily="34" charset="-122"/>
-                <a:cs typeface="Arial" pitchFamily="34" charset="-120"/>
-              </a:rPr>
-              <a:t>→</a:t>
-            </a:r>
-            <a:endParaRPr lang="en-US" sz="2000" dirty="0"/>
-          </a:p>
-        </p:txBody>
-      </p:sp>
-      <p:sp>
-        <p:nvSpPr>
-          <p:cNvPr id="17" name="Shape 15"/>
-          <p:cNvSpPr/>
-          <p:nvPr/>
-        </p:nvSpPr>
-        <p:spPr>
-          <a:xfrm>
-            <a:off x="9641434" y="1800808"/>
-            <a:ext cx="1998878" cy="2194560"/>
-          </a:xfrm>
-          <a:prstGeom prst="roundRect">
-            <a:avLst/>
-          </a:prstGeom>
-          <a:solidFill>
-            <a:srgbClr val="FBEAEA"/>
-          </a:solidFill>
-          <a:ln w="15875">
-            <a:solidFill>
-              <a:srgbClr val="C62828"/>
-            </a:solidFill>
-            <a:prstDash val="solid"/>
-          </a:ln>
-        </p:spPr>
-        <p:txBody>
-          <a:bodyPr/>
-          <a:lstStyle/>
-          <a:p>
-            <a:endParaRPr lang="es-ES"/>
-          </a:p>
-        </p:txBody>
-      </p:sp>
-      <p:sp>
-        <p:nvSpPr>
-          <p:cNvPr id="18" name="Text 16"/>
-          <p:cNvSpPr/>
-          <p:nvPr/>
-        </p:nvSpPr>
-        <p:spPr>
-          <a:xfrm>
-            <a:off x="9687154" y="1846528"/>
-            <a:ext cx="1907438" cy="2103120"/>
-          </a:xfrm>
-          <a:prstGeom prst="rect">
-            <a:avLst/>
-          </a:prstGeom>
-          <a:noFill/>
-          <a:ln/>
-        </p:spPr>
-        <p:txBody>
-          <a:bodyPr wrap="square" rtlCol="0" anchor="ctr"/>
-          <a:lstStyle/>
-          <a:p>
-            <a:pPr marL="0" indent="0" algn="ctr">
-              <a:buNone/>
-            </a:pPr>
-            <a:r>
-              <a:rPr lang="en-US" sz="1800" dirty="0">
-                <a:solidFill>
-                  <a:srgbClr val="212121"/>
-                </a:solidFill>
-                <a:latin typeface="Arial" pitchFamily="34" charset="0"/>
-                <a:ea typeface="Arial" pitchFamily="34" charset="-122"/>
-                <a:cs typeface="Arial" pitchFamily="34" charset="-120"/>
-              </a:rPr>
-              <a:t>Terminal, depurador</a:t>
-            </a:r>
-            <a:endParaRPr lang="en-US" sz="1800" dirty="0"/>
-          </a:p>
-          <a:p>
-            <a:pPr marL="0" indent="0" algn="ctr">
-              <a:buNone/>
-            </a:pPr>
-            <a:r>
-              <a:rPr lang="en-US" sz="1800" dirty="0">
-                <a:solidFill>
-                  <a:srgbClr val="212121"/>
-                </a:solidFill>
-                <a:latin typeface="Arial" pitchFamily="34" charset="0"/>
-                <a:ea typeface="Arial" pitchFamily="34" charset="-122"/>
-                <a:cs typeface="Arial" pitchFamily="34" charset="-120"/>
-              </a:rPr>
-              <a:t>y extensiones ya</a:t>
-            </a:r>
-            <a:endParaRPr lang="en-US" sz="1800" dirty="0"/>
-          </a:p>
-          <a:p>
-            <a:pPr marL="0" indent="0" algn="ctr">
-              <a:buNone/>
-            </a:pPr>
-            <a:r>
-              <a:rPr lang="en-US" sz="1800" dirty="0">
-                <a:solidFill>
-                  <a:srgbClr val="212121"/>
-                </a:solidFill>
-                <a:latin typeface="Arial" pitchFamily="34" charset="0"/>
-                <a:ea typeface="Arial" pitchFamily="34" charset="-122"/>
-                <a:cs typeface="Arial" pitchFamily="34" charset="-120"/>
-              </a:rPr>
-              <a:t>corren dentro</a:t>
-            </a:r>
-            <a:endParaRPr lang="en-US" sz="1800" dirty="0"/>
-          </a:p>
-        </p:txBody>
-      </p:sp>
-      <p:sp>
-        <p:nvSpPr>
-          <p:cNvPr id="19" name="Text 17"/>
-          <p:cNvSpPr/>
-          <p:nvPr/>
-        </p:nvSpPr>
-        <p:spPr>
-          <a:xfrm>
-            <a:off x="502920" y="4424576"/>
-            <a:ext cx="11091672" cy="1188720"/>
-          </a:xfrm>
-          <a:prstGeom prst="rect">
-            <a:avLst/>
-          </a:prstGeom>
-          <a:noFill/>
-          <a:ln/>
-        </p:spPr>
-        <p:txBody>
-          <a:bodyPr wrap="square" rtlCol="0" anchor="t"/>
-          <a:lstStyle/>
-          <a:p>
-            <a:pPr marL="0" indent="0" algn="ctr">
-              <a:buNone/>
-            </a:pPr>
-            <a:r>
-              <a:rPr lang="en-US" sz="2200" dirty="0">
-                <a:solidFill>
-                  <a:srgbClr val="212121"/>
-                </a:solidFill>
-                <a:latin typeface="Arial" pitchFamily="34" charset="0"/>
-                <a:ea typeface="Arial" pitchFamily="34" charset="-122"/>
-                <a:cs typeface="Arial" pitchFamily="34" charset="-120"/>
-              </a:rPr>
-              <a:t>La ventana de VS Code no cambia de aspecto en ningún momento de este proceso: lo único que delata que estás dentro es una etiqueta en la esquina inferior izquierda.</a:t>
-            </a:r>
-            <a:endParaRPr lang="en-US" sz="2200" dirty="0"/>
-          </a:p>
-        </p:txBody>
-      </p:sp>
+        </p:spPr>
+      </p:pic>
     </p:spTree>
   </p:cSld>
   <p:clrMapOvr>
@@ -3236,7 +2295,7 @@
                 <a:ea typeface="Arial" pitchFamily="34" charset="-122"/>
                 <a:cs typeface="Arial" pitchFamily="34" charset="-120"/>
               </a:rPr>
-              <a:t>Cómo se nota que estás dentro</a:t>
+              <a:t>El fichero que lo describe todo</a:t>
             </a:r>
             <a:endParaRPr lang="en-US" sz="2600" dirty="0"/>
           </a:p>
@@ -3281,16 +2340,41 @@
           </a:p>
         </p:txBody>
       </p:sp>
-      <p:sp>
-        <p:nvSpPr>
-          <p:cNvPr id="5" name="Shape 3"/>
-          <p:cNvSpPr/>
-          <p:nvPr/>
-        </p:nvSpPr>
-        <p:spPr>
-          <a:xfrm>
-            <a:off x="548640" y="1280160"/>
-            <a:ext cx="11091672" cy="1463040"/>
+      <p:pic>
+        <p:nvPicPr>
+          <p:cNvPr id="5" name="Image 0" descr="C:/Users/Aitor/Documents/apuntes-profe/acceso-a-datos/docs/tema0/img/devcontainers/devcontainer_json_anatomia.png"/>
+          <p:cNvPicPr>
+            <a:picLocks noChangeAspect="1"/>
+          </p:cNvPicPr>
+          <p:nvPr/>
+        </p:nvPicPr>
+        <p:blipFill>
+          <a:blip r:embed="rId3"/>
+          <a:srcRect t="5192" b="6372"/>
+          <a:stretch>
+            <a:fillRect/>
+          </a:stretch>
+        </p:blipFill>
+        <p:spPr>
+          <a:xfrm>
+            <a:off x="1909309" y="868680"/>
+            <a:ext cx="8370334" cy="4175450"/>
+          </a:xfrm>
+          <a:prstGeom prst="rect">
+            <a:avLst/>
+          </a:prstGeom>
+        </p:spPr>
+      </p:pic>
+      <p:sp>
+        <p:nvSpPr>
+          <p:cNvPr id="6" name="Shape 3"/>
+          <p:cNvSpPr/>
+          <p:nvPr/>
+        </p:nvSpPr>
+        <p:spPr>
+          <a:xfrm>
+            <a:off x="548640" y="5257800"/>
+            <a:ext cx="11091672" cy="1051560"/>
           </a:xfrm>
           <a:prstGeom prst="roundRect">
             <a:avLst/>
@@ -3315,14 +2399,14 @@
       </p:sp>
       <p:sp>
         <p:nvSpPr>
-          <p:cNvPr id="6" name="Text 4"/>
-          <p:cNvSpPr/>
-          <p:nvPr/>
-        </p:nvSpPr>
-        <p:spPr>
-          <a:xfrm>
-            <a:off x="822960" y="1371600"/>
-            <a:ext cx="10543032" cy="1280160"/>
+          <p:cNvPr id="7" name="Text 4"/>
+          <p:cNvSpPr/>
+          <p:nvPr/>
+        </p:nvSpPr>
+        <p:spPr>
+          <a:xfrm>
+            <a:off x="822960" y="5349240"/>
+            <a:ext cx="10543032" cy="868680"/>
           </a:xfrm>
           <a:prstGeom prst="rect">
             <a:avLst/>
@@ -3338,7 +2422,7 @@
               <a:buNone/>
             </a:pPr>
             <a:r>
-              <a:rPr lang="en-US" sz="2500" dirty="0">
+              <a:rPr lang="en-US" sz="1800" dirty="0">
                 <a:solidFill>
                   <a:srgbClr val="212121"/>
                 </a:solidFill>
@@ -3346,48 +2430,9 @@
                 <a:ea typeface="Arial" pitchFamily="34" charset="-122"/>
                 <a:cs typeface="Arial" pitchFamily="34" charset="-120"/>
               </a:rPr>
-              <a:t>Lo único que delata que estás dentro de un contenedor es una etiqueta en la esquina inferior izquierda de VS Code, con el nombre del Dev Container activo.</a:t>
+              <a:t>En vez de image, puede usar dockerComposeFile y service: el mismo docker-compose.yml que levanta tu base de datos puede levantar también el contenedor donde vive tu editor.</a:t>
             </a:r>
-            <a:endParaRPr lang="en-US" sz="2500" dirty="0"/>
-          </a:p>
-        </p:txBody>
-      </p:sp>
-      <p:sp>
-        <p:nvSpPr>
-          <p:cNvPr id="7" name="Text 5"/>
-          <p:cNvSpPr/>
-          <p:nvPr/>
-        </p:nvSpPr>
-        <p:spPr>
-          <a:xfrm>
-            <a:off x="548640" y="3291840"/>
-            <a:ext cx="11091672" cy="1554480"/>
-          </a:xfrm>
-          <a:prstGeom prst="rect">
-            <a:avLst/>
-          </a:prstGeom>
-          <a:noFill/>
-          <a:ln/>
-        </p:spPr>
-        <p:txBody>
-          <a:bodyPr wrap="square" rtlCol="0" anchor="t"/>
-          <a:lstStyle/>
-          <a:p>
-            <a:pPr marL="0" indent="0">
-              <a:buNone/>
-            </a:pPr>
-            <a:r>
-              <a:rPr lang="en-US" sz="2400" dirty="0">
-                <a:solidFill>
-                  <a:srgbClr val="212121"/>
-                </a:solidFill>
-                <a:latin typeface="Arial" pitchFamily="34" charset="0"/>
-                <a:ea typeface="Arial" pitchFamily="34" charset="-122"/>
-                <a:cs typeface="Arial" pitchFamily="34" charset="-120"/>
-              </a:rPr>
-              <a:t>Lo vas a comprobar tú mismo en la Actividad 0.7: compararás qué responde la terminal dentro del contenedor frente a la terminal de tu propio sistema operativo.</a:t>
-            </a:r>
-            <a:endParaRPr lang="en-US" sz="2400" dirty="0"/>
+            <a:endParaRPr lang="en-US" sz="1800" dirty="0"/>
           </a:p>
         </p:txBody>
       </p:sp>
@@ -3481,7 +2526,7 @@
                 <a:ea typeface="Arial" pitchFamily="34" charset="-122"/>
                 <a:cs typeface="Arial" pitchFamily="34" charset="-120"/>
               </a:rPr>
-              <a:t>El fichero que lo describe todo</a:t>
+              <a:t>La relación con Docker, en una frase</a:t>
             </a:r>
             <a:endParaRPr lang="en-US" sz="2600" dirty="0"/>
           </a:p>
@@ -3526,1061 +2571,33 @@
           </a:p>
         </p:txBody>
       </p:sp>
-      <p:sp>
-        <p:nvSpPr>
-          <p:cNvPr id="5" name="Text 3"/>
-          <p:cNvSpPr/>
-          <p:nvPr/>
-        </p:nvSpPr>
-        <p:spPr>
-          <a:xfrm>
-            <a:off x="548640" y="1005840"/>
-            <a:ext cx="11091672" cy="548640"/>
+      <p:pic>
+        <p:nvPicPr>
+          <p:cNvPr id="5" name="Image 0" descr="C:/Users/Aitor/Documents/apuntes-profe/acceso-a-datos/docs/tema0/img/devcontainers/devcontainer_vs_contenedor_servicio.png"/>
+          <p:cNvPicPr>
+            <a:picLocks noChangeAspect="1"/>
+          </p:cNvPicPr>
+          <p:nvPr/>
+        </p:nvPicPr>
+        <p:blipFill>
+          <a:blip r:embed="rId3"/>
+          <a:stretch>
+            <a:fillRect/>
+          </a:stretch>
+        </p:blipFill>
+        <p:spPr>
+          <a:xfrm>
+            <a:off x="2928804" y="939245"/>
+            <a:ext cx="6331344" cy="3571333"/>
           </a:xfrm>
           <a:prstGeom prst="rect">
             <a:avLst/>
           </a:prstGeom>
-          <a:noFill/>
-          <a:ln/>
-        </p:spPr>
-        <p:txBody>
-          <a:bodyPr wrap="square" rtlCol="0" anchor="t"/>
-          <a:lstStyle/>
-          <a:p>
-            <a:pPr marL="0" indent="0">
-              <a:buNone/>
-            </a:pPr>
-            <a:r>
-              <a:rPr lang="en-US" sz="2100" dirty="0">
-                <a:solidFill>
-                  <a:srgbClr val="212121"/>
-                </a:solidFill>
-                <a:latin typeface="Arial" pitchFamily="34" charset="0"/>
-                <a:ea typeface="Arial" pitchFamily="34" charset="-122"/>
-                <a:cs typeface="Arial" pitchFamily="34" charset="-120"/>
-              </a:rPr>
-              <a:t>Todo lo anterior lo define un único fichero, .devcontainer/devcontainer.json, en la raíz del proyecto:</a:t>
-            </a:r>
-            <a:endParaRPr lang="en-US" sz="2100" dirty="0"/>
-          </a:p>
-        </p:txBody>
-      </p:sp>
-      <p:sp>
-        <p:nvSpPr>
-          <p:cNvPr id="6" name="Shape 4"/>
-          <p:cNvSpPr/>
-          <p:nvPr/>
-        </p:nvSpPr>
-        <p:spPr>
-          <a:xfrm>
-            <a:off x="548640" y="1828800"/>
-            <a:ext cx="11091672" cy="4114800"/>
-          </a:xfrm>
-          <a:prstGeom prst="rect">
-            <a:avLst/>
-          </a:prstGeom>
-          <a:solidFill>
-            <a:srgbClr val="ECEFF1"/>
-          </a:solidFill>
-          <a:ln w="12700">
-            <a:solidFill>
-              <a:srgbClr val="EEEEEE"/>
-            </a:solidFill>
-            <a:prstDash val="solid"/>
-          </a:ln>
-        </p:spPr>
-        <p:txBody>
-          <a:bodyPr/>
-          <a:lstStyle/>
-          <a:p>
-            <a:endParaRPr lang="es-ES"/>
-          </a:p>
-        </p:txBody>
-      </p:sp>
-      <p:sp>
-        <p:nvSpPr>
-          <p:cNvPr id="7" name="Shape 5"/>
-          <p:cNvSpPr/>
-          <p:nvPr/>
-        </p:nvSpPr>
-        <p:spPr>
-          <a:xfrm>
-            <a:off x="548640" y="1828800"/>
-            <a:ext cx="73152" cy="4114800"/>
-          </a:xfrm>
-          <a:prstGeom prst="rect">
-            <a:avLst/>
-          </a:prstGeom>
-          <a:solidFill>
-            <a:srgbClr val="E64A19"/>
-          </a:solidFill>
-          <a:ln w="12700">
-            <a:solidFill>
-              <a:srgbClr val="E64A19"/>
-            </a:solidFill>
-            <a:prstDash val="solid"/>
-          </a:ln>
-        </p:spPr>
-        <p:txBody>
-          <a:bodyPr/>
-          <a:lstStyle/>
-          <a:p>
-            <a:endParaRPr lang="es-ES"/>
-          </a:p>
-        </p:txBody>
-      </p:sp>
-      <p:sp>
-        <p:nvSpPr>
-          <p:cNvPr id="8" name="Text 6"/>
-          <p:cNvSpPr/>
-          <p:nvPr/>
-        </p:nvSpPr>
-        <p:spPr>
-          <a:xfrm>
-            <a:off x="822960" y="1938528"/>
-            <a:ext cx="10588752" cy="3895344"/>
-          </a:xfrm>
-          <a:prstGeom prst="rect">
-            <a:avLst/>
-          </a:prstGeom>
-          <a:noFill/>
-          <a:ln/>
-        </p:spPr>
-        <p:txBody>
-          <a:bodyPr wrap="square" rtlCol="0" anchor="t"/>
-          <a:lstStyle/>
-          <a:p>
-            <a:pPr marL="0" indent="0">
-              <a:buNone/>
-            </a:pPr>
-            <a:r>
-              <a:rPr lang="en-US" sz="1900" dirty="0">
-                <a:solidFill>
-                  <a:srgbClr val="263238"/>
-                </a:solidFill>
-                <a:latin typeface="Courier New" pitchFamily="34" charset="0"/>
-                <a:ea typeface="Courier New" pitchFamily="34" charset="-122"/>
-                <a:cs typeface="Courier New" pitchFamily="34" charset="-120"/>
-              </a:rPr>
-              <a:t>{</a:t>
-            </a:r>
-            <a:endParaRPr lang="en-US" sz="1900" dirty="0"/>
-          </a:p>
-          <a:p>
-            <a:pPr marL="0" indent="0">
-              <a:buNone/>
-            </a:pPr>
-            <a:r>
-              <a:rPr lang="en-US" sz="1900" dirty="0">
-                <a:solidFill>
-                  <a:srgbClr val="263238"/>
-                </a:solidFill>
-                <a:latin typeface="Courier New" pitchFamily="34" charset="0"/>
-                <a:ea typeface="Courier New" pitchFamily="34" charset="-122"/>
-                <a:cs typeface="Courier New" pitchFamily="34" charset="-120"/>
-              </a:rPr>
-              <a:t>  "name": "Entorno del curso",</a:t>
-            </a:r>
-            <a:endParaRPr lang="en-US" sz="1900" dirty="0"/>
-          </a:p>
-          <a:p>
-            <a:pPr marL="0" indent="0">
-              <a:buNone/>
-            </a:pPr>
-            <a:r>
-              <a:rPr lang="en-US" sz="1900" dirty="0">
-                <a:solidFill>
-                  <a:srgbClr val="263238"/>
-                </a:solidFill>
-                <a:latin typeface="Courier New" pitchFamily="34" charset="0"/>
-                <a:ea typeface="Courier New" pitchFamily="34" charset="-122"/>
-                <a:cs typeface="Courier New" pitchFamily="34" charset="-120"/>
-              </a:rPr>
-              <a:t>  "image": "mcr.microsoft.com/devcontainers/base:debian-12",</a:t>
-            </a:r>
-            <a:endParaRPr lang="en-US" sz="1900" dirty="0"/>
-          </a:p>
-          <a:p>
-            <a:pPr marL="0" indent="0">
-              <a:buNone/>
-            </a:pPr>
-            <a:r>
-              <a:rPr lang="en-US" sz="1900" dirty="0">
-                <a:solidFill>
-                  <a:srgbClr val="263238"/>
-                </a:solidFill>
-                <a:latin typeface="Courier New" pitchFamily="34" charset="0"/>
-                <a:ea typeface="Courier New" pitchFamily="34" charset="-122"/>
-                <a:cs typeface="Courier New" pitchFamily="34" charset="-120"/>
-              </a:rPr>
-              <a:t>  "forwardPorts": [5432],</a:t>
-            </a:r>
-            <a:endParaRPr lang="en-US" sz="1900" dirty="0"/>
-          </a:p>
-          <a:p>
-            <a:pPr marL="0" indent="0">
-              <a:buNone/>
-            </a:pPr>
-            <a:r>
-              <a:rPr lang="en-US" sz="1900" dirty="0">
-                <a:solidFill>
-                  <a:srgbClr val="263238"/>
-                </a:solidFill>
-                <a:latin typeface="Courier New" pitchFamily="34" charset="0"/>
-                <a:ea typeface="Courier New" pitchFamily="34" charset="-122"/>
-                <a:cs typeface="Courier New" pitchFamily="34" charset="-120"/>
-              </a:rPr>
-              <a:t>  "postCreateCommand": "echo 'Entorno listo'",</a:t>
-            </a:r>
-            <a:endParaRPr lang="en-US" sz="1900" dirty="0"/>
-          </a:p>
-          <a:p>
-            <a:pPr marL="0" indent="0">
-              <a:buNone/>
-            </a:pPr>
-            <a:r>
-              <a:rPr lang="en-US" sz="1900" dirty="0">
-                <a:solidFill>
-                  <a:srgbClr val="263238"/>
-                </a:solidFill>
-                <a:latin typeface="Courier New" pitchFamily="34" charset="0"/>
-                <a:ea typeface="Courier New" pitchFamily="34" charset="-122"/>
-                <a:cs typeface="Courier New" pitchFamily="34" charset="-120"/>
-              </a:rPr>
-              <a:t>  "customizations": {</a:t>
-            </a:r>
-            <a:endParaRPr lang="en-US" sz="1900" dirty="0"/>
-          </a:p>
-          <a:p>
-            <a:pPr marL="0" indent="0">
-              <a:buNone/>
-            </a:pPr>
-            <a:r>
-              <a:rPr lang="en-US" sz="1900" dirty="0">
-                <a:solidFill>
-                  <a:srgbClr val="263238"/>
-                </a:solidFill>
-                <a:latin typeface="Courier New" pitchFamily="34" charset="0"/>
-                <a:ea typeface="Courier New" pitchFamily="34" charset="-122"/>
-                <a:cs typeface="Courier New" pitchFamily="34" charset="-120"/>
-              </a:rPr>
-              <a:t>    "vscode": {</a:t>
-            </a:r>
-            <a:endParaRPr lang="en-US" sz="1900" dirty="0"/>
-          </a:p>
-          <a:p>
-            <a:pPr marL="0" indent="0">
-              <a:buNone/>
-            </a:pPr>
-            <a:r>
-              <a:rPr lang="en-US" sz="1900" dirty="0">
-                <a:solidFill>
-                  <a:srgbClr val="263238"/>
-                </a:solidFill>
-                <a:latin typeface="Courier New" pitchFamily="34" charset="0"/>
-                <a:ea typeface="Courier New" pitchFamily="34" charset="-122"/>
-                <a:cs typeface="Courier New" pitchFamily="34" charset="-120"/>
-              </a:rPr>
-              <a:t>      "extensions": ["ms-python.python"]</a:t>
-            </a:r>
-            <a:endParaRPr lang="en-US" sz="1900" dirty="0"/>
-          </a:p>
-          <a:p>
-            <a:pPr marL="0" indent="0">
-              <a:buNone/>
-            </a:pPr>
-            <a:r>
-              <a:rPr lang="en-US" sz="1900" dirty="0">
-                <a:solidFill>
-                  <a:srgbClr val="263238"/>
-                </a:solidFill>
-                <a:latin typeface="Courier New" pitchFamily="34" charset="0"/>
-                <a:ea typeface="Courier New" pitchFamily="34" charset="-122"/>
-                <a:cs typeface="Courier New" pitchFamily="34" charset="-120"/>
-              </a:rPr>
-              <a:t>    }</a:t>
-            </a:r>
-            <a:endParaRPr lang="en-US" sz="1900" dirty="0"/>
-          </a:p>
-          <a:p>
-            <a:pPr marL="0" indent="0">
-              <a:buNone/>
-            </a:pPr>
-            <a:r>
-              <a:rPr lang="en-US" sz="1900" dirty="0">
-                <a:solidFill>
-                  <a:srgbClr val="263238"/>
-                </a:solidFill>
-                <a:latin typeface="Courier New" pitchFamily="34" charset="0"/>
-                <a:ea typeface="Courier New" pitchFamily="34" charset="-122"/>
-                <a:cs typeface="Courier New" pitchFamily="34" charset="-120"/>
-              </a:rPr>
-              <a:t>  }</a:t>
-            </a:r>
-            <a:endParaRPr lang="en-US" sz="1900" dirty="0"/>
-          </a:p>
-          <a:p>
-            <a:pPr marL="0" indent="0">
-              <a:buNone/>
-            </a:pPr>
-            <a:r>
-              <a:rPr lang="en-US" sz="1900" dirty="0">
-                <a:solidFill>
-                  <a:srgbClr val="263238"/>
-                </a:solidFill>
-                <a:latin typeface="Courier New" pitchFamily="34" charset="0"/>
-                <a:ea typeface="Courier New" pitchFamily="34" charset="-122"/>
-                <a:cs typeface="Courier New" pitchFamily="34" charset="-120"/>
-              </a:rPr>
-              <a:t>}</a:t>
-            </a:r>
-            <a:endParaRPr lang="en-US" sz="1900" dirty="0"/>
-          </a:p>
-        </p:txBody>
-      </p:sp>
-    </p:spTree>
-  </p:cSld>
-  <p:clrMapOvr>
-    <a:masterClrMapping/>
-  </p:clrMapOvr>
-</p:sld>
-</file>
-
-<file path=ppt/slides/slide7.xml><?xml version="1.0" encoding="utf-8"?>
-<p:sld xmlns:a="http://schemas.openxmlformats.org/drawingml/2006/main" xmlns:r="http://schemas.openxmlformats.org/officeDocument/2006/relationships" xmlns:p="http://schemas.openxmlformats.org/presentationml/2006/main">
-  <p:cSld name="Slide 7">
-    <p:spTree>
-      <p:nvGrpSpPr>
-        <p:cNvPr id="1" name=""/>
-        <p:cNvGrpSpPr/>
-        <p:nvPr/>
-      </p:nvGrpSpPr>
-      <p:grpSpPr>
-        <a:xfrm>
-          <a:off x="0" y="0"/>
-          <a:ext cx="0" cy="0"/>
-          <a:chOff x="0" y="0"/>
-          <a:chExt cx="0" cy="0"/>
-        </a:xfrm>
-      </p:grpSpPr>
-      <p:sp>
-        <p:nvSpPr>
-          <p:cNvPr id="2" name="Shape 0"/>
-          <p:cNvSpPr/>
-          <p:nvPr/>
-        </p:nvSpPr>
-        <p:spPr>
-          <a:xfrm>
-            <a:off x="0" y="0"/>
-            <a:ext cx="12188952" cy="777240"/>
-          </a:xfrm>
-          <a:prstGeom prst="rect">
-            <a:avLst/>
-          </a:prstGeom>
-          <a:solidFill>
-            <a:srgbClr val="7F0000"/>
-          </a:solidFill>
-          <a:ln w="12700">
-            <a:solidFill>
-              <a:srgbClr val="7F0000"/>
-            </a:solidFill>
-            <a:prstDash val="solid"/>
-          </a:ln>
-        </p:spPr>
-        <p:txBody>
-          <a:bodyPr/>
-          <a:lstStyle/>
-          <a:p>
-            <a:endParaRPr lang="es-ES"/>
-          </a:p>
-        </p:txBody>
-      </p:sp>
-      <p:sp>
-        <p:nvSpPr>
-          <p:cNvPr id="3" name="Text 1"/>
-          <p:cNvSpPr/>
-          <p:nvPr/>
-        </p:nvSpPr>
-        <p:spPr>
-          <a:xfrm>
-            <a:off x="365760" y="0"/>
-            <a:ext cx="11457432" cy="777240"/>
-          </a:xfrm>
-          <a:prstGeom prst="rect">
-            <a:avLst/>
-          </a:prstGeom>
-          <a:noFill/>
-          <a:ln/>
-        </p:spPr>
-        <p:txBody>
-          <a:bodyPr wrap="square" rtlCol="0" anchor="ctr"/>
-          <a:lstStyle/>
-          <a:p>
-            <a:pPr marL="0" indent="0">
-              <a:buNone/>
-            </a:pPr>
-            <a:r>
-              <a:rPr lang="en-US" sz="2600" b="1" dirty="0">
-                <a:solidFill>
-                  <a:srgbClr val="FFFFFF"/>
-                </a:solidFill>
-                <a:latin typeface="Arial" pitchFamily="34" charset="0"/>
-                <a:ea typeface="Arial" pitchFamily="34" charset="-122"/>
-                <a:cs typeface="Arial" pitchFamily="34" charset="-120"/>
-              </a:rPr>
-              <a:t>Qué hace cada campo</a:t>
-            </a:r>
-            <a:endParaRPr lang="en-US" sz="2600" dirty="0"/>
-          </a:p>
-        </p:txBody>
-      </p:sp>
-      <p:sp>
-        <p:nvSpPr>
-          <p:cNvPr id="4" name="Text 2"/>
-          <p:cNvSpPr/>
-          <p:nvPr/>
-        </p:nvSpPr>
-        <p:spPr>
-          <a:xfrm>
-            <a:off x="548640" y="6473952"/>
-            <a:ext cx="11091672" cy="292608"/>
-          </a:xfrm>
-          <a:prstGeom prst="rect">
-            <a:avLst/>
-          </a:prstGeom>
-          <a:noFill/>
-          <a:ln/>
-        </p:spPr>
-        <p:txBody>
-          <a:bodyPr wrap="square" rtlCol="0" anchor="ctr"/>
-          <a:lstStyle/>
-          <a:p>
-            <a:pPr marL="0" indent="0" algn="r">
-              <a:buNone/>
-            </a:pPr>
-            <a:r>
-              <a:rPr lang="en-US" sz="1100" dirty="0">
-                <a:solidFill>
-                  <a:srgbClr val="757575"/>
-                </a:solidFill>
-                <a:latin typeface="Arial" pitchFamily="34" charset="0"/>
-                <a:ea typeface="Arial" pitchFamily="34" charset="-122"/>
-                <a:cs typeface="Arial" pitchFamily="34" charset="-120"/>
-              </a:rPr>
-              <a:t>Acceso a Datos — Dev Containers</a:t>
-            </a:r>
-            <a:endParaRPr lang="en-US" sz="1100" dirty="0"/>
-          </a:p>
-        </p:txBody>
-      </p:sp>
-      <p:sp>
-        <p:nvSpPr>
-          <p:cNvPr id="5" name="Text 3"/>
-          <p:cNvSpPr/>
-          <p:nvPr/>
-        </p:nvSpPr>
-        <p:spPr>
-          <a:xfrm>
-            <a:off x="613954" y="1219884"/>
-            <a:ext cx="11091672" cy="5212080"/>
-          </a:xfrm>
-          <a:prstGeom prst="rect">
-            <a:avLst/>
-          </a:prstGeom>
-          <a:noFill/>
-          <a:ln/>
-        </p:spPr>
-        <p:txBody>
-          <a:bodyPr wrap="square" rtlCol="0" anchor="t"/>
-          <a:lstStyle/>
-          <a:p>
-            <a:pPr marL="0" indent="0">
-              <a:spcAft>
-                <a:spcPts val="600"/>
-              </a:spcAft>
-              <a:buNone/>
-            </a:pPr>
-            <a:r>
-              <a:rPr lang="en-US" sz="2100" b="1" dirty="0">
-                <a:solidFill>
-                  <a:srgbClr val="212121"/>
-                </a:solidFill>
-                <a:latin typeface="Arial" pitchFamily="34" charset="0"/>
-                <a:ea typeface="Arial" pitchFamily="34" charset="-122"/>
-                <a:cs typeface="Arial" pitchFamily="34" charset="-120"/>
-              </a:rPr>
-              <a:t>image</a:t>
-            </a:r>
-            <a:endParaRPr lang="en-US" sz="2100" dirty="0"/>
-          </a:p>
-          <a:p>
-            <a:pPr marL="762000" lvl="1" indent="-381000">
-              <a:spcAft>
-                <a:spcPts val="2000"/>
-              </a:spcAft>
-              <a:buSzPct val="100000"/>
-              <a:buChar char="•"/>
-            </a:pPr>
-            <a:r>
-              <a:rPr lang="en-US" sz="2100" dirty="0">
-                <a:solidFill>
-                  <a:srgbClr val="212121"/>
-                </a:solidFill>
-                <a:latin typeface="Arial" pitchFamily="34" charset="0"/>
-                <a:ea typeface="Arial" pitchFamily="34" charset="-122"/>
-                <a:cs typeface="Arial" pitchFamily="34" charset="-120"/>
-              </a:rPr>
-              <a:t>la imagen que se usa para construir el contenedor donde vas a trabajar — aquí no aloja una base de datos, sino un sistema base para programar.</a:t>
-            </a:r>
-            <a:endParaRPr lang="en-US" sz="2100" dirty="0"/>
-          </a:p>
-          <a:p>
-            <a:pPr marL="0" indent="0">
-              <a:spcAft>
-                <a:spcPts val="600"/>
-              </a:spcAft>
-              <a:buNone/>
-            </a:pPr>
-            <a:r>
-              <a:rPr lang="en-US" sz="2100" b="1" dirty="0">
-                <a:solidFill>
-                  <a:srgbClr val="212121"/>
-                </a:solidFill>
-                <a:latin typeface="Arial" pitchFamily="34" charset="0"/>
-                <a:ea typeface="Arial" pitchFamily="34" charset="-122"/>
-                <a:cs typeface="Arial" pitchFamily="34" charset="-120"/>
-              </a:rPr>
-              <a:t>forwardPorts</a:t>
-            </a:r>
-            <a:endParaRPr lang="en-US" sz="2100" dirty="0"/>
-          </a:p>
-          <a:p>
-            <a:pPr marL="762000" lvl="1" indent="-381000">
-              <a:spcAft>
-                <a:spcPts val="2000"/>
-              </a:spcAft>
-              <a:buSzPct val="100000"/>
-              <a:buChar char="•"/>
-            </a:pPr>
-            <a:r>
-              <a:rPr lang="en-US" sz="2100" dirty="0">
-                <a:solidFill>
-                  <a:srgbClr val="212121"/>
-                </a:solidFill>
-                <a:latin typeface="Arial" pitchFamily="34" charset="0"/>
-                <a:ea typeface="Arial" pitchFamily="34" charset="-122"/>
-                <a:cs typeface="Arial" pitchFamily="34" charset="-120"/>
-              </a:rPr>
-              <a:t>te deja ver desde tu navegador algo que corre dentro del contenedor.</a:t>
-            </a:r>
-            <a:endParaRPr lang="en-US" sz="2100" dirty="0"/>
-          </a:p>
-          <a:p>
-            <a:pPr marL="0" indent="0">
-              <a:spcAft>
-                <a:spcPts val="600"/>
-              </a:spcAft>
-              <a:buNone/>
-            </a:pPr>
-            <a:r>
-              <a:rPr lang="en-US" sz="2100" b="1" dirty="0">
-                <a:solidFill>
-                  <a:srgbClr val="212121"/>
-                </a:solidFill>
-                <a:latin typeface="Arial" pitchFamily="34" charset="0"/>
-                <a:ea typeface="Arial" pitchFamily="34" charset="-122"/>
-                <a:cs typeface="Arial" pitchFamily="34" charset="-120"/>
-              </a:rPr>
-              <a:t>postCreateCommand</a:t>
-            </a:r>
-            <a:endParaRPr lang="en-US" sz="2100" dirty="0"/>
-          </a:p>
-          <a:p>
-            <a:pPr marL="762000" lvl="1" indent="-381000">
-              <a:spcAft>
-                <a:spcPts val="2000"/>
-              </a:spcAft>
-              <a:buSzPct val="100000"/>
-              <a:buChar char="•"/>
-            </a:pPr>
-            <a:r>
-              <a:rPr lang="en-US" sz="2100" dirty="0">
-                <a:solidFill>
-                  <a:srgbClr val="212121"/>
-                </a:solidFill>
-                <a:latin typeface="Arial" pitchFamily="34" charset="0"/>
-                <a:ea typeface="Arial" pitchFamily="34" charset="-122"/>
-                <a:cs typeface="Arial" pitchFamily="34" charset="-120"/>
-              </a:rPr>
-              <a:t>un comando que se ejecuta una única vez, justo tras crear el contenedor — típico para instalar dependencias.</a:t>
-            </a:r>
-            <a:endParaRPr lang="en-US" sz="2100" dirty="0"/>
-          </a:p>
-          <a:p>
-            <a:pPr marL="0" indent="0">
-              <a:spcAft>
-                <a:spcPts val="600"/>
-              </a:spcAft>
-              <a:buNone/>
-            </a:pPr>
-            <a:r>
-              <a:rPr lang="en-US" sz="2100" b="1" dirty="0">
-                <a:solidFill>
-                  <a:srgbClr val="212121"/>
-                </a:solidFill>
-                <a:latin typeface="Arial" pitchFamily="34" charset="0"/>
-                <a:ea typeface="Arial" pitchFamily="34" charset="-122"/>
-                <a:cs typeface="Arial" pitchFamily="34" charset="-120"/>
-              </a:rPr>
-              <a:t>customizations.vscode.extensions</a:t>
-            </a:r>
-            <a:endParaRPr lang="en-US" sz="2100" dirty="0"/>
-          </a:p>
-          <a:p>
-            <a:pPr marL="762000" lvl="1" indent="-381000">
-              <a:spcAft>
-                <a:spcPts val="800"/>
-              </a:spcAft>
-              <a:buSzPct val="100000"/>
-              <a:buChar char="•"/>
-            </a:pPr>
-            <a:r>
-              <a:rPr lang="en-US" sz="2100" dirty="0">
-                <a:solidFill>
-                  <a:srgbClr val="212121"/>
-                </a:solidFill>
-                <a:latin typeface="Arial" pitchFamily="34" charset="0"/>
-                <a:ea typeface="Arial" pitchFamily="34" charset="-122"/>
-                <a:cs typeface="Arial" pitchFamily="34" charset="-120"/>
-              </a:rPr>
-              <a:t>instala solas, dentro del contenedor, las extensiones que necesitas.</a:t>
-            </a:r>
-            <a:endParaRPr lang="en-US" sz="2100" dirty="0"/>
-          </a:p>
-        </p:txBody>
-      </p:sp>
-    </p:spTree>
-  </p:cSld>
-  <p:clrMapOvr>
-    <a:masterClrMapping/>
-  </p:clrMapOvr>
-</p:sld>
-</file>
-
-<file path=ppt/slides/slide8.xml><?xml version="1.0" encoding="utf-8"?>
-<p:sld xmlns:a="http://schemas.openxmlformats.org/drawingml/2006/main" xmlns:r="http://schemas.openxmlformats.org/officeDocument/2006/relationships" xmlns:p="http://schemas.openxmlformats.org/presentationml/2006/main">
-  <p:cSld name="Slide 8">
-    <p:spTree>
-      <p:nvGrpSpPr>
-        <p:cNvPr id="1" name=""/>
-        <p:cNvGrpSpPr/>
-        <p:nvPr/>
-      </p:nvGrpSpPr>
-      <p:grpSpPr>
-        <a:xfrm>
-          <a:off x="0" y="0"/>
-          <a:ext cx="0" cy="0"/>
-          <a:chOff x="0" y="0"/>
-          <a:chExt cx="0" cy="0"/>
-        </a:xfrm>
-      </p:grpSpPr>
-      <p:sp>
-        <p:nvSpPr>
-          <p:cNvPr id="2" name="Shape 0"/>
-          <p:cNvSpPr/>
-          <p:nvPr/>
-        </p:nvSpPr>
-        <p:spPr>
-          <a:xfrm>
-            <a:off x="0" y="0"/>
-            <a:ext cx="12188952" cy="777240"/>
-          </a:xfrm>
-          <a:prstGeom prst="rect">
-            <a:avLst/>
-          </a:prstGeom>
-          <a:solidFill>
-            <a:srgbClr val="7F0000"/>
-          </a:solidFill>
-          <a:ln w="12700">
-            <a:solidFill>
-              <a:srgbClr val="7F0000"/>
-            </a:solidFill>
-            <a:prstDash val="solid"/>
-          </a:ln>
-        </p:spPr>
-        <p:txBody>
-          <a:bodyPr/>
-          <a:lstStyle/>
-          <a:p>
-            <a:endParaRPr lang="es-ES"/>
-          </a:p>
-        </p:txBody>
-      </p:sp>
-      <p:sp>
-        <p:nvSpPr>
-          <p:cNvPr id="3" name="Text 1"/>
-          <p:cNvSpPr/>
-          <p:nvPr/>
-        </p:nvSpPr>
-        <p:spPr>
-          <a:xfrm>
-            <a:off x="365760" y="0"/>
-            <a:ext cx="11457432" cy="777240"/>
-          </a:xfrm>
-          <a:prstGeom prst="rect">
-            <a:avLst/>
-          </a:prstGeom>
-          <a:noFill/>
-          <a:ln/>
-        </p:spPr>
-        <p:txBody>
-          <a:bodyPr wrap="square" rtlCol="0" anchor="ctr"/>
-          <a:lstStyle/>
-          <a:p>
-            <a:pPr marL="0" indent="0">
-              <a:buNone/>
-            </a:pPr>
-            <a:r>
-              <a:rPr lang="en-US" sz="2600" b="1" dirty="0">
-                <a:solidFill>
-                  <a:srgbClr val="FFFFFF"/>
-                </a:solidFill>
-                <a:latin typeface="Arial" pitchFamily="34" charset="0"/>
-                <a:ea typeface="Arial" pitchFamily="34" charset="-122"/>
-                <a:cs typeface="Arial" pitchFamily="34" charset="-120"/>
-              </a:rPr>
-              <a:t>También puede apoyarse en Docker Compose</a:t>
-            </a:r>
-            <a:endParaRPr lang="en-US" sz="2600" dirty="0"/>
-          </a:p>
-        </p:txBody>
-      </p:sp>
-      <p:sp>
-        <p:nvSpPr>
-          <p:cNvPr id="4" name="Text 2"/>
-          <p:cNvSpPr/>
-          <p:nvPr/>
-        </p:nvSpPr>
-        <p:spPr>
-          <a:xfrm>
-            <a:off x="548640" y="6473952"/>
-            <a:ext cx="11091672" cy="292608"/>
-          </a:xfrm>
-          <a:prstGeom prst="rect">
-            <a:avLst/>
-          </a:prstGeom>
-          <a:noFill/>
-          <a:ln/>
-        </p:spPr>
-        <p:txBody>
-          <a:bodyPr wrap="square" rtlCol="0" anchor="ctr"/>
-          <a:lstStyle/>
-          <a:p>
-            <a:pPr marL="0" indent="0" algn="r">
-              <a:buNone/>
-            </a:pPr>
-            <a:r>
-              <a:rPr lang="en-US" sz="1100" dirty="0">
-                <a:solidFill>
-                  <a:srgbClr val="757575"/>
-                </a:solidFill>
-                <a:latin typeface="Arial" pitchFamily="34" charset="0"/>
-                <a:ea typeface="Arial" pitchFamily="34" charset="-122"/>
-                <a:cs typeface="Arial" pitchFamily="34" charset="-120"/>
-              </a:rPr>
-              <a:t>Acceso a Datos — Dev Containers</a:t>
-            </a:r>
-            <a:endParaRPr lang="en-US" sz="1100" dirty="0"/>
-          </a:p>
-        </p:txBody>
-      </p:sp>
-      <p:sp>
-        <p:nvSpPr>
-          <p:cNvPr id="5" name="Shape 3"/>
-          <p:cNvSpPr/>
-          <p:nvPr/>
-        </p:nvSpPr>
-        <p:spPr>
-          <a:xfrm>
-            <a:off x="548640" y="1765352"/>
-            <a:ext cx="11091672" cy="1645920"/>
-          </a:xfrm>
-          <a:prstGeom prst="roundRect">
-            <a:avLst/>
-          </a:prstGeom>
-          <a:solidFill>
-            <a:srgbClr val="FBE9E7"/>
-          </a:solidFill>
-          <a:ln w="19050">
-            <a:solidFill>
-              <a:srgbClr val="E64A19"/>
-            </a:solidFill>
-            <a:prstDash val="solid"/>
-          </a:ln>
-        </p:spPr>
-        <p:txBody>
-          <a:bodyPr/>
-          <a:lstStyle/>
-          <a:p>
-            <a:endParaRPr lang="es-ES"/>
-          </a:p>
-        </p:txBody>
-      </p:sp>
-      <p:sp>
-        <p:nvSpPr>
-          <p:cNvPr id="6" name="Text 4"/>
-          <p:cNvSpPr/>
-          <p:nvPr/>
-        </p:nvSpPr>
-        <p:spPr>
-          <a:xfrm>
-            <a:off x="822960" y="1856792"/>
-            <a:ext cx="10543032" cy="1463040"/>
-          </a:xfrm>
-          <a:prstGeom prst="rect">
-            <a:avLst/>
-          </a:prstGeom>
-          <a:noFill/>
-          <a:ln/>
-        </p:spPr>
-        <p:txBody>
-          <a:bodyPr wrap="square" rtlCol="0" anchor="ctr"/>
-          <a:lstStyle/>
-          <a:p>
-            <a:pPr marL="0" indent="0">
-              <a:buNone/>
-            </a:pPr>
-            <a:r>
-              <a:rPr lang="en-US" sz="2400" dirty="0">
-                <a:solidFill>
-                  <a:srgbClr val="212121"/>
-                </a:solidFill>
-                <a:latin typeface="Arial" pitchFamily="34" charset="0"/>
-                <a:ea typeface="Arial" pitchFamily="34" charset="-122"/>
-                <a:cs typeface="Arial" pitchFamily="34" charset="-120"/>
-              </a:rPr>
-              <a:t>En vez de image, un devcontainer.json puede usar dockerComposeFile y service para decir "mi entorno de desarrollo es este servicio concreto de este docker-compose.yml".</a:t>
-            </a:r>
-            <a:endParaRPr lang="en-US" sz="2400" dirty="0"/>
-          </a:p>
-        </p:txBody>
-      </p:sp>
-      <p:sp>
-        <p:nvSpPr>
-          <p:cNvPr id="7" name="Text 5"/>
-          <p:cNvSpPr/>
-          <p:nvPr/>
-        </p:nvSpPr>
-        <p:spPr>
-          <a:xfrm>
-            <a:off x="548640" y="3914192"/>
-            <a:ext cx="11091672" cy="1737360"/>
-          </a:xfrm>
-          <a:prstGeom prst="rect">
-            <a:avLst/>
-          </a:prstGeom>
-          <a:noFill/>
-          <a:ln/>
-        </p:spPr>
-        <p:txBody>
-          <a:bodyPr wrap="square" rtlCol="0" anchor="t"/>
-          <a:lstStyle/>
-          <a:p>
-            <a:pPr marL="0" indent="0">
-              <a:buNone/>
-            </a:pPr>
-            <a:r>
-              <a:rPr lang="en-US" sz="2300" dirty="0">
-                <a:solidFill>
-                  <a:srgbClr val="212121"/>
-                </a:solidFill>
-                <a:latin typeface="Arial" pitchFamily="34" charset="0"/>
-                <a:ea typeface="Arial" pitchFamily="34" charset="-122"/>
-                <a:cs typeface="Arial" pitchFamily="34" charset="-120"/>
-              </a:rPr>
-              <a:t>Así, el mismo fichero de Compose que levanta tu base de datos puede levantar, en otro de sus servicios, el contenedor donde vive tu editor: los dos usos de Docker conviven en el mismo fichero.</a:t>
-            </a:r>
-            <a:endParaRPr lang="en-US" sz="2300" dirty="0"/>
-          </a:p>
-        </p:txBody>
-      </p:sp>
-    </p:spTree>
-  </p:cSld>
-  <p:clrMapOvr>
-    <a:masterClrMapping/>
-  </p:clrMapOvr>
-</p:sld>
-</file>
-
-<file path=ppt/slides/slide9.xml><?xml version="1.0" encoding="utf-8"?>
-<p:sld xmlns:a="http://schemas.openxmlformats.org/drawingml/2006/main" xmlns:r="http://schemas.openxmlformats.org/officeDocument/2006/relationships" xmlns:p="http://schemas.openxmlformats.org/presentationml/2006/main">
-  <p:cSld name="Slide 9">
-    <p:spTree>
-      <p:nvGrpSpPr>
-        <p:cNvPr id="1" name=""/>
-        <p:cNvGrpSpPr/>
-        <p:nvPr/>
-      </p:nvGrpSpPr>
-      <p:grpSpPr>
-        <a:xfrm>
-          <a:off x="0" y="0"/>
-          <a:ext cx="0" cy="0"/>
-          <a:chOff x="0" y="0"/>
-          <a:chExt cx="0" cy="0"/>
-        </a:xfrm>
-      </p:grpSpPr>
-      <p:sp>
-        <p:nvSpPr>
-          <p:cNvPr id="2" name="Shape 0"/>
-          <p:cNvSpPr/>
-          <p:nvPr/>
-        </p:nvSpPr>
-        <p:spPr>
-          <a:xfrm>
-            <a:off x="0" y="0"/>
-            <a:ext cx="12188952" cy="777240"/>
-          </a:xfrm>
-          <a:prstGeom prst="rect">
-            <a:avLst/>
-          </a:prstGeom>
-          <a:solidFill>
-            <a:srgbClr val="7F0000"/>
-          </a:solidFill>
-          <a:ln w="12700">
-            <a:solidFill>
-              <a:srgbClr val="7F0000"/>
-            </a:solidFill>
-            <a:prstDash val="solid"/>
-          </a:ln>
-        </p:spPr>
-        <p:txBody>
-          <a:bodyPr/>
-          <a:lstStyle/>
-          <a:p>
-            <a:endParaRPr lang="es-ES"/>
-          </a:p>
-        </p:txBody>
-      </p:sp>
-      <p:sp>
-        <p:nvSpPr>
-          <p:cNvPr id="3" name="Text 1"/>
-          <p:cNvSpPr/>
-          <p:nvPr/>
-        </p:nvSpPr>
-        <p:spPr>
-          <a:xfrm>
-            <a:off x="365760" y="0"/>
-            <a:ext cx="11457432" cy="777240"/>
-          </a:xfrm>
-          <a:prstGeom prst="rect">
-            <a:avLst/>
-          </a:prstGeom>
-          <a:noFill/>
-          <a:ln/>
-        </p:spPr>
-        <p:txBody>
-          <a:bodyPr wrap="square" rtlCol="0" anchor="ctr"/>
-          <a:lstStyle/>
-          <a:p>
-            <a:pPr marL="0" indent="0">
-              <a:buNone/>
-            </a:pPr>
-            <a:r>
-              <a:rPr lang="en-US" sz="2600" b="1" dirty="0">
-                <a:solidFill>
-                  <a:srgbClr val="FFFFFF"/>
-                </a:solidFill>
-                <a:latin typeface="Arial" pitchFamily="34" charset="0"/>
-                <a:ea typeface="Arial" pitchFamily="34" charset="-122"/>
-                <a:cs typeface="Arial" pitchFamily="34" charset="-120"/>
-              </a:rPr>
-              <a:t>La relación con Docker, en una frase</a:t>
-            </a:r>
-            <a:endParaRPr lang="en-US" sz="2600" dirty="0"/>
-          </a:p>
-        </p:txBody>
-      </p:sp>
-      <p:sp>
-        <p:nvSpPr>
-          <p:cNvPr id="4" name="Text 2"/>
-          <p:cNvSpPr/>
-          <p:nvPr/>
-        </p:nvSpPr>
-        <p:spPr>
-          <a:xfrm>
-            <a:off x="548640" y="6473952"/>
-            <a:ext cx="11091672" cy="292608"/>
-          </a:xfrm>
-          <a:prstGeom prst="rect">
-            <a:avLst/>
-          </a:prstGeom>
-          <a:noFill/>
-          <a:ln/>
-        </p:spPr>
-        <p:txBody>
-          <a:bodyPr wrap="square" rtlCol="0" anchor="ctr"/>
-          <a:lstStyle/>
-          <a:p>
-            <a:pPr marL="0" indent="0" algn="r">
-              <a:buNone/>
-            </a:pPr>
-            <a:r>
-              <a:rPr lang="en-US" sz="1100" dirty="0">
-                <a:solidFill>
-                  <a:srgbClr val="757575"/>
-                </a:solidFill>
-                <a:latin typeface="Arial" pitchFamily="34" charset="0"/>
-                <a:ea typeface="Arial" pitchFamily="34" charset="-122"/>
-                <a:cs typeface="Arial" pitchFamily="34" charset="-120"/>
-              </a:rPr>
-              <a:t>Acceso a Datos — Dev Containers</a:t>
-            </a:r>
-            <a:endParaRPr lang="en-US" sz="1100" dirty="0"/>
-          </a:p>
-        </p:txBody>
-      </p:sp>
-      <p:sp>
-        <p:nvSpPr>
-          <p:cNvPr id="5" name="Text 3"/>
-          <p:cNvSpPr/>
-          <p:nvPr/>
-        </p:nvSpPr>
-        <p:spPr>
-          <a:xfrm>
-            <a:off x="548640" y="1233507"/>
-            <a:ext cx="11091672" cy="1280160"/>
-          </a:xfrm>
-          <a:prstGeom prst="rect">
-            <a:avLst/>
-          </a:prstGeom>
-          <a:noFill/>
-          <a:ln/>
-        </p:spPr>
-        <p:txBody>
-          <a:bodyPr wrap="square" rtlCol="0" anchor="t"/>
-          <a:lstStyle/>
-          <a:p>
-            <a:pPr marL="0" indent="0">
-              <a:buNone/>
-            </a:pPr>
-            <a:r>
-              <a:rPr lang="en-US" sz="2100" dirty="0">
-                <a:solidFill>
-                  <a:srgbClr val="212121"/>
-                </a:solidFill>
-                <a:latin typeface="Arial" pitchFamily="34" charset="0"/>
-                <a:ea typeface="Arial" pitchFamily="34" charset="-122"/>
-                <a:cs typeface="Arial" pitchFamily="34" charset="-120"/>
-              </a:rPr>
-              <a:t>Dev Containers no sustituye a Docker: se apoya en él. Docker crea y ejecuta el contenedor; Dev Containers le dice a tu editor cómo conectarse y usarlo como tu ordenador de toda la vida.</a:t>
-            </a:r>
-            <a:endParaRPr lang="en-US" sz="2100" dirty="0"/>
-          </a:p>
-        </p:txBody>
-      </p:sp>
+        </p:spPr>
+      </p:pic>
       <p:graphicFrame>
         <p:nvGraphicFramePr>
-          <p:cNvPr id="10" name="Table 0"/>
+          <p:cNvPr id="7" name="Table 0"/>
           <p:cNvGraphicFramePr>
             <a:graphicFrameLocks noGrp="1"/>
           </p:cNvGraphicFramePr>
@@ -4593,8 +2610,8 @@
           </p:nvPr>
         </p:nvGraphicFramePr>
         <p:xfrm>
-          <a:off x="548640" y="2606040"/>
-          <a:ext cx="11091672" cy="3364992"/>
+          <a:off x="548640" y="4526280"/>
+          <a:ext cx="11091672" cy="2194560"/>
         </p:xfrm>
         <a:graphic>
           <a:graphicData uri="http://schemas.openxmlformats.org/drawingml/2006/table">
@@ -4623,7 +2640,7 @@
                   </a:extLst>
                 </a:gridCol>
               </a:tblGrid>
-              <a:tr h="841248">
+              <a:tr h="548640">
                 <a:tc>
                   <a:txBody>
                     <a:bodyPr/>
@@ -4632,7 +2649,7 @@
                       <a:pPr marL="0" indent="0" algn="ctr">
                         <a:buNone/>
                       </a:pPr>
-                      <a:endParaRPr lang="en-US" sz="1700" dirty="0">
+                      <a:endParaRPr lang="en-US" sz="1500" dirty="0">
                         <a:latin typeface="Arial" charset="0"/>
                         <a:ea typeface="Arial" charset="0"/>
                         <a:cs typeface="Arial" charset="0"/>
@@ -4690,7 +2707,7 @@
                         <a:buNone/>
                       </a:pPr>
                       <a:r>
-                        <a:rPr lang="en-US" sz="1700" b="1" dirty="0">
+                        <a:rPr lang="en-US" sz="1500" b="1" dirty="0">
                           <a:solidFill>
                             <a:srgbClr val="FFFFFF"/>
                           </a:solidFill>
@@ -4700,7 +2717,7 @@
                         </a:rPr>
                         <a:t>Contenedor de servicio</a:t>
                       </a:r>
-                      <a:endParaRPr lang="en-US" sz="1700" dirty="0">
+                      <a:endParaRPr lang="en-US" sz="1500" dirty="0">
                         <a:latin typeface="Arial" charset="0"/>
                         <a:ea typeface="Arial" charset="0"/>
                         <a:cs typeface="Arial" charset="0"/>
@@ -4758,7 +2775,7 @@
                         <a:buNone/>
                       </a:pPr>
                       <a:r>
-                        <a:rPr lang="en-US" sz="1700" b="1" dirty="0">
+                        <a:rPr lang="en-US" sz="1500" b="1" dirty="0">
                           <a:solidFill>
                             <a:srgbClr val="FFFFFF"/>
                           </a:solidFill>
@@ -4768,7 +2785,7 @@
                         </a:rPr>
                         <a:t>Dev Container</a:t>
                       </a:r>
-                      <a:endParaRPr lang="en-US" sz="1700" dirty="0">
+                      <a:endParaRPr lang="en-US" sz="1500" dirty="0">
                         <a:latin typeface="Arial" charset="0"/>
                         <a:ea typeface="Arial" charset="0"/>
                         <a:cs typeface="Arial" charset="0"/>
@@ -4823,7 +2840,7 @@
                   </a:ext>
                 </a:extLst>
               </a:tr>
-              <a:tr h="841248">
+              <a:tr h="548640">
                 <a:tc>
                   <a:txBody>
                     <a:bodyPr/>
@@ -4833,7 +2850,7 @@
                         <a:buNone/>
                       </a:pPr>
                       <a:r>
-                        <a:rPr lang="en-US" sz="1600" b="1" dirty="0">
+                        <a:rPr lang="en-US" sz="1400" b="1" dirty="0">
                           <a:solidFill>
                             <a:srgbClr val="212121"/>
                           </a:solidFill>
@@ -4843,7 +2860,7 @@
                         </a:rPr>
                         <a:t>¿Qué hace?</a:t>
                       </a:r>
-                      <a:endParaRPr lang="en-US" sz="1600" dirty="0">
+                      <a:endParaRPr lang="en-US" sz="1400" dirty="0">
                         <a:latin typeface="Arial" charset="0"/>
                         <a:ea typeface="Arial" charset="0"/>
                         <a:cs typeface="Arial" charset="0"/>
@@ -4901,7 +2918,7 @@
                         <a:buNone/>
                       </a:pPr>
                       <a:r>
-                        <a:rPr lang="en-US" sz="1600" dirty="0">
+                        <a:rPr lang="en-US" sz="1400" dirty="0">
                           <a:solidFill>
                             <a:srgbClr val="212121"/>
                           </a:solidFill>
@@ -4911,7 +2928,7 @@
                         </a:rPr>
                         <a:t>Ejecuta un programa al que tu código se conecta desde fuera</a:t>
                       </a:r>
-                      <a:endParaRPr lang="en-US" sz="1600" dirty="0">
+                      <a:endParaRPr lang="en-US" sz="1400" dirty="0">
                         <a:latin typeface="Arial" charset="0"/>
                         <a:ea typeface="Arial" charset="0"/>
                         <a:cs typeface="Arial" charset="0"/>
@@ -4969,7 +2986,7 @@
                         <a:buNone/>
                       </a:pPr>
                       <a:r>
-                        <a:rPr lang="en-US" sz="1600" dirty="0">
+                        <a:rPr lang="en-US" sz="1400" dirty="0">
                           <a:solidFill>
                             <a:srgbClr val="212121"/>
                           </a:solidFill>
@@ -4979,7 +2996,7 @@
                         </a:rPr>
                         <a:t>Aloja tu propio entorno de programación</a:t>
                       </a:r>
-                      <a:endParaRPr lang="en-US" sz="1600" dirty="0">
+                      <a:endParaRPr lang="en-US" sz="1400" dirty="0">
                         <a:latin typeface="Arial" charset="0"/>
                         <a:ea typeface="Arial" charset="0"/>
                         <a:cs typeface="Arial" charset="0"/>
@@ -5034,7 +3051,7 @@
                   </a:ext>
                 </a:extLst>
               </a:tr>
-              <a:tr h="841248">
+              <a:tr h="548640">
                 <a:tc>
                   <a:txBody>
                     <a:bodyPr/>
@@ -5044,7 +3061,7 @@
                         <a:buNone/>
                       </a:pPr>
                       <a:r>
-                        <a:rPr lang="en-US" sz="1600" b="1" dirty="0">
+                        <a:rPr lang="en-US" sz="1400" b="1" dirty="0">
                           <a:solidFill>
                             <a:srgbClr val="212121"/>
                           </a:solidFill>
@@ -5054,7 +3071,7 @@
                         </a:rPr>
                         <a:t>¿Quién se conecta?</a:t>
                       </a:r>
-                      <a:endParaRPr lang="en-US" sz="1600" dirty="0">
+                      <a:endParaRPr lang="en-US" sz="1400" dirty="0">
                         <a:latin typeface="Arial" charset="0"/>
                         <a:ea typeface="Arial" charset="0"/>
                         <a:cs typeface="Arial" charset="0"/>
@@ -5112,7 +3129,7 @@
                         <a:buNone/>
                       </a:pPr>
                       <a:r>
-                        <a:rPr lang="en-US" sz="1600" dirty="0">
+                        <a:rPr lang="en-US" sz="1400" dirty="0">
                           <a:solidFill>
                             <a:srgbClr val="212121"/>
                           </a:solidFill>
@@ -5122,7 +3139,7 @@
                         </a:rPr>
                         <a:t>Tu aplicación, por red y puerto</a:t>
                       </a:r>
-                      <a:endParaRPr lang="en-US" sz="1600" dirty="0">
+                      <a:endParaRPr lang="en-US" sz="1400" dirty="0">
                         <a:latin typeface="Arial" charset="0"/>
                         <a:ea typeface="Arial" charset="0"/>
                         <a:cs typeface="Arial" charset="0"/>
@@ -5180,7 +3197,7 @@
                         <a:buNone/>
                       </a:pPr>
                       <a:r>
-                        <a:rPr lang="en-US" sz="1600" dirty="0">
+                        <a:rPr lang="en-US" sz="1400" dirty="0">
                           <a:solidFill>
                             <a:srgbClr val="212121"/>
                           </a:solidFill>
@@ -5190,7 +3207,7 @@
                         </a:rPr>
                         <a:t>Tu editor, directamente desde dentro</a:t>
                       </a:r>
-                      <a:endParaRPr lang="en-US" sz="1600" dirty="0">
+                      <a:endParaRPr lang="en-US" sz="1400" dirty="0">
                         <a:latin typeface="Arial" charset="0"/>
                         <a:ea typeface="Arial" charset="0"/>
                         <a:cs typeface="Arial" charset="0"/>
@@ -5245,7 +3262,7 @@
                   </a:ext>
                 </a:extLst>
               </a:tr>
-              <a:tr h="841248">
+              <a:tr h="548640">
                 <a:tc>
                   <a:txBody>
                     <a:bodyPr/>
@@ -5255,7 +3272,7 @@
                         <a:buNone/>
                       </a:pPr>
                       <a:r>
-                        <a:rPr lang="en-US" sz="1600" b="1" dirty="0">
+                        <a:rPr lang="en-US" sz="1400" b="1" dirty="0">
                           <a:solidFill>
                             <a:srgbClr val="212121"/>
                           </a:solidFill>
@@ -5265,7 +3282,7 @@
                         </a:rPr>
                         <a:t>Ejemplo de imagen</a:t>
                       </a:r>
-                      <a:endParaRPr lang="en-US" sz="1600" dirty="0">
+                      <a:endParaRPr lang="en-US" sz="1400" dirty="0">
                         <a:latin typeface="Arial" charset="0"/>
                         <a:ea typeface="Arial" charset="0"/>
                         <a:cs typeface="Arial" charset="0"/>
@@ -5323,7 +3340,7 @@
                         <a:buNone/>
                       </a:pPr>
                       <a:r>
-                        <a:rPr lang="en-US" sz="1600" dirty="0">
+                        <a:rPr lang="en-US" sz="1400" dirty="0">
                           <a:solidFill>
                             <a:srgbClr val="212121"/>
                           </a:solidFill>
@@ -5333,7 +3350,7 @@
                         </a:rPr>
                         <a:t>postgres:18-alpine</a:t>
                       </a:r>
-                      <a:endParaRPr lang="en-US" sz="1600" dirty="0">
+                      <a:endParaRPr lang="en-US" sz="1400" dirty="0">
                         <a:latin typeface="Arial" charset="0"/>
                         <a:ea typeface="Arial" charset="0"/>
                         <a:cs typeface="Arial" charset="0"/>
@@ -5391,7 +3408,7 @@
                         <a:buNone/>
                       </a:pPr>
                       <a:r>
-                        <a:rPr lang="en-US" sz="1600" dirty="0">
+                        <a:rPr lang="en-US" sz="1400" dirty="0">
                           <a:solidFill>
                             <a:srgbClr val="212121"/>
                           </a:solidFill>
@@ -5401,7 +3418,7 @@
                         </a:rPr>
                         <a:t>mcr.microsoft.com/devcontainers/base:debian-12</a:t>
                       </a:r>
-                      <a:endParaRPr lang="en-US" sz="1600" dirty="0">
+                      <a:endParaRPr lang="en-US" sz="1400" dirty="0">
                         <a:latin typeface="Arial" charset="0"/>
                         <a:ea typeface="Arial" charset="0"/>
                         <a:cs typeface="Arial" charset="0"/>
@@ -5460,6 +3477,709 @@
           </a:graphicData>
         </a:graphic>
       </p:graphicFrame>
+    </p:spTree>
+  </p:cSld>
+  <p:clrMapOvr>
+    <a:masterClrMapping/>
+  </p:clrMapOvr>
+</p:sld>
+</file>
+
+<file path=ppt/slides/slide7.xml><?xml version="1.0" encoding="utf-8"?>
+<p:sld xmlns:a="http://schemas.openxmlformats.org/drawingml/2006/main" xmlns:r="http://schemas.openxmlformats.org/officeDocument/2006/relationships" xmlns:p="http://schemas.openxmlformats.org/presentationml/2006/main">
+  <p:cSld name="Slide 7">
+    <p:spTree>
+      <p:nvGrpSpPr>
+        <p:cNvPr id="1" name=""/>
+        <p:cNvGrpSpPr/>
+        <p:nvPr/>
+      </p:nvGrpSpPr>
+      <p:grpSpPr>
+        <a:xfrm>
+          <a:off x="0" y="0"/>
+          <a:ext cx="0" cy="0"/>
+          <a:chOff x="0" y="0"/>
+          <a:chExt cx="0" cy="0"/>
+        </a:xfrm>
+      </p:grpSpPr>
+      <p:sp>
+        <p:nvSpPr>
+          <p:cNvPr id="2" name="Shape 0"/>
+          <p:cNvSpPr/>
+          <p:nvPr/>
+        </p:nvSpPr>
+        <p:spPr>
+          <a:xfrm>
+            <a:off x="0" y="0"/>
+            <a:ext cx="12188952" cy="777240"/>
+          </a:xfrm>
+          <a:prstGeom prst="rect">
+            <a:avLst/>
+          </a:prstGeom>
+          <a:solidFill>
+            <a:srgbClr val="7F0000"/>
+          </a:solidFill>
+          <a:ln w="12700">
+            <a:solidFill>
+              <a:srgbClr val="7F0000"/>
+            </a:solidFill>
+            <a:prstDash val="solid"/>
+          </a:ln>
+        </p:spPr>
+        <p:txBody>
+          <a:bodyPr/>
+          <a:lstStyle/>
+          <a:p>
+            <a:endParaRPr lang="es-ES"/>
+          </a:p>
+        </p:txBody>
+      </p:sp>
+      <p:sp>
+        <p:nvSpPr>
+          <p:cNvPr id="3" name="Text 1"/>
+          <p:cNvSpPr/>
+          <p:nvPr/>
+        </p:nvSpPr>
+        <p:spPr>
+          <a:xfrm>
+            <a:off x="365760" y="0"/>
+            <a:ext cx="11457432" cy="777240"/>
+          </a:xfrm>
+          <a:prstGeom prst="rect">
+            <a:avLst/>
+          </a:prstGeom>
+          <a:noFill/>
+          <a:ln/>
+        </p:spPr>
+        <p:txBody>
+          <a:bodyPr wrap="square" rtlCol="0" anchor="ctr"/>
+          <a:lstStyle/>
+          <a:p>
+            <a:pPr marL="0" indent="0">
+              <a:buNone/>
+            </a:pPr>
+            <a:r>
+              <a:rPr lang="en-US" sz="2600" b="1" dirty="0">
+                <a:solidFill>
+                  <a:srgbClr val="FFFFFF"/>
+                </a:solidFill>
+                <a:latin typeface="Arial" pitchFamily="34" charset="0"/>
+                <a:ea typeface="Arial" pitchFamily="34" charset="-122"/>
+                <a:cs typeface="Arial" pitchFamily="34" charset="-120"/>
+              </a:rPr>
+              <a:t>Ideas clave</a:t>
+            </a:r>
+            <a:endParaRPr lang="en-US" sz="2600" dirty="0"/>
+          </a:p>
+        </p:txBody>
+      </p:sp>
+      <p:sp>
+        <p:nvSpPr>
+          <p:cNvPr id="4" name="Text 2"/>
+          <p:cNvSpPr/>
+          <p:nvPr/>
+        </p:nvSpPr>
+        <p:spPr>
+          <a:xfrm>
+            <a:off x="548640" y="6473952"/>
+            <a:ext cx="11091672" cy="292608"/>
+          </a:xfrm>
+          <a:prstGeom prst="rect">
+            <a:avLst/>
+          </a:prstGeom>
+          <a:noFill/>
+          <a:ln/>
+        </p:spPr>
+        <p:txBody>
+          <a:bodyPr wrap="square" rtlCol="0" anchor="ctr"/>
+          <a:lstStyle/>
+          <a:p>
+            <a:pPr marL="0" indent="0" algn="r">
+              <a:buNone/>
+            </a:pPr>
+            <a:r>
+              <a:rPr lang="en-US" sz="1100" dirty="0">
+                <a:solidFill>
+                  <a:srgbClr val="757575"/>
+                </a:solidFill>
+                <a:latin typeface="Arial" pitchFamily="34" charset="0"/>
+                <a:ea typeface="Arial" pitchFamily="34" charset="-122"/>
+                <a:cs typeface="Arial" pitchFamily="34" charset="-120"/>
+              </a:rPr>
+              <a:t>Acceso a Datos — Dev Containers</a:t>
+            </a:r>
+            <a:endParaRPr lang="en-US" sz="1100" dirty="0"/>
+          </a:p>
+        </p:txBody>
+      </p:sp>
+      <p:sp>
+        <p:nvSpPr>
+          <p:cNvPr id="5" name="Shape 3"/>
+          <p:cNvSpPr/>
+          <p:nvPr/>
+        </p:nvSpPr>
+        <p:spPr>
+          <a:xfrm>
+            <a:off x="548640" y="1097280"/>
+            <a:ext cx="5431536" cy="2286000"/>
+          </a:xfrm>
+          <a:prstGeom prst="roundRect">
+            <a:avLst/>
+          </a:prstGeom>
+          <a:solidFill>
+            <a:srgbClr val="FBEAEA"/>
+          </a:solidFill>
+          <a:ln w="15875">
+            <a:solidFill>
+              <a:srgbClr val="C62828"/>
+            </a:solidFill>
+            <a:prstDash val="solid"/>
+          </a:ln>
+        </p:spPr>
+        <p:txBody>
+          <a:bodyPr/>
+          <a:lstStyle/>
+          <a:p>
+            <a:endParaRPr lang="es-ES"/>
+          </a:p>
+        </p:txBody>
+      </p:sp>
+      <p:sp>
+        <p:nvSpPr>
+          <p:cNvPr id="6" name="Shape 4"/>
+          <p:cNvSpPr/>
+          <p:nvPr/>
+        </p:nvSpPr>
+        <p:spPr>
+          <a:xfrm>
+            <a:off x="731520" y="1965960"/>
+            <a:ext cx="548640" cy="548640"/>
+          </a:xfrm>
+          <a:prstGeom prst="ellipse">
+            <a:avLst/>
+          </a:prstGeom>
+          <a:solidFill>
+            <a:srgbClr val="E64A19"/>
+          </a:solidFill>
+          <a:ln w="12700">
+            <a:solidFill>
+              <a:srgbClr val="E64A19"/>
+            </a:solidFill>
+            <a:prstDash val="solid"/>
+          </a:ln>
+        </p:spPr>
+        <p:txBody>
+          <a:bodyPr/>
+          <a:lstStyle/>
+          <a:p>
+            <a:endParaRPr lang="es-ES"/>
+          </a:p>
+        </p:txBody>
+      </p:sp>
+      <p:sp>
+        <p:nvSpPr>
+          <p:cNvPr id="7" name="Text 5"/>
+          <p:cNvSpPr/>
+          <p:nvPr/>
+        </p:nvSpPr>
+        <p:spPr>
+          <a:xfrm>
+            <a:off x="731520" y="1965960"/>
+            <a:ext cx="548640" cy="548640"/>
+          </a:xfrm>
+          <a:prstGeom prst="rect">
+            <a:avLst/>
+          </a:prstGeom>
+          <a:noFill/>
+          <a:ln/>
+        </p:spPr>
+        <p:txBody>
+          <a:bodyPr wrap="square" rtlCol="0" anchor="ctr"/>
+          <a:lstStyle/>
+          <a:p>
+            <a:pPr marL="0" indent="0" algn="ctr">
+              <a:buNone/>
+            </a:pPr>
+            <a:r>
+              <a:rPr lang="en-US" sz="2000" b="1" dirty="0">
+                <a:solidFill>
+                  <a:srgbClr val="FFFFFF"/>
+                </a:solidFill>
+                <a:latin typeface="Arial" pitchFamily="34" charset="0"/>
+                <a:ea typeface="Arial" pitchFamily="34" charset="-122"/>
+                <a:cs typeface="Arial" pitchFamily="34" charset="-120"/>
+              </a:rPr>
+              <a:t>1</a:t>
+            </a:r>
+            <a:endParaRPr lang="en-US" sz="2000" dirty="0"/>
+          </a:p>
+        </p:txBody>
+      </p:sp>
+      <p:sp>
+        <p:nvSpPr>
+          <p:cNvPr id="8" name="Text 6"/>
+          <p:cNvSpPr/>
+          <p:nvPr/>
+        </p:nvSpPr>
+        <p:spPr>
+          <a:xfrm>
+            <a:off x="1417320" y="1170432"/>
+            <a:ext cx="4379976" cy="2139696"/>
+          </a:xfrm>
+          <a:prstGeom prst="rect">
+            <a:avLst/>
+          </a:prstGeom>
+          <a:noFill/>
+          <a:ln/>
+        </p:spPr>
+        <p:txBody>
+          <a:bodyPr wrap="square" rtlCol="0" anchor="ctr"/>
+          <a:lstStyle/>
+          <a:p>
+            <a:pPr marL="0" indent="0">
+              <a:buNone/>
+            </a:pPr>
+            <a:r>
+              <a:rPr lang="en-US" sz="2200" dirty="0">
+                <a:solidFill>
+                  <a:srgbClr val="212121"/>
+                </a:solidFill>
+                <a:latin typeface="Arial" pitchFamily="34" charset="0"/>
+                <a:ea typeface="Arial" pitchFamily="34" charset="-122"/>
+                <a:cs typeface="Arial" pitchFamily="34" charset="-120"/>
+              </a:rPr>
+              <a:t>Un Dev Container usa Docker para alojar tu propio entorno de programación, no un servicio.</a:t>
+            </a:r>
+            <a:endParaRPr lang="en-US" sz="2200" dirty="0"/>
+          </a:p>
+        </p:txBody>
+      </p:sp>
+      <p:sp>
+        <p:nvSpPr>
+          <p:cNvPr id="9" name="Shape 7"/>
+          <p:cNvSpPr/>
+          <p:nvPr/>
+        </p:nvSpPr>
+        <p:spPr>
+          <a:xfrm>
+            <a:off x="6208776" y="1097280"/>
+            <a:ext cx="5431536" cy="2286000"/>
+          </a:xfrm>
+          <a:prstGeom prst="roundRect">
+            <a:avLst/>
+          </a:prstGeom>
+          <a:solidFill>
+            <a:srgbClr val="FBEAEA"/>
+          </a:solidFill>
+          <a:ln w="15875">
+            <a:solidFill>
+              <a:srgbClr val="C62828"/>
+            </a:solidFill>
+            <a:prstDash val="solid"/>
+          </a:ln>
+        </p:spPr>
+        <p:txBody>
+          <a:bodyPr/>
+          <a:lstStyle/>
+          <a:p>
+            <a:endParaRPr lang="es-ES"/>
+          </a:p>
+        </p:txBody>
+      </p:sp>
+      <p:sp>
+        <p:nvSpPr>
+          <p:cNvPr id="10" name="Shape 8"/>
+          <p:cNvSpPr/>
+          <p:nvPr/>
+        </p:nvSpPr>
+        <p:spPr>
+          <a:xfrm>
+            <a:off x="6391656" y="1965960"/>
+            <a:ext cx="548640" cy="548640"/>
+          </a:xfrm>
+          <a:prstGeom prst="ellipse">
+            <a:avLst/>
+          </a:prstGeom>
+          <a:solidFill>
+            <a:srgbClr val="E64A19"/>
+          </a:solidFill>
+          <a:ln w="12700">
+            <a:solidFill>
+              <a:srgbClr val="E64A19"/>
+            </a:solidFill>
+            <a:prstDash val="solid"/>
+          </a:ln>
+        </p:spPr>
+        <p:txBody>
+          <a:bodyPr/>
+          <a:lstStyle/>
+          <a:p>
+            <a:endParaRPr lang="es-ES"/>
+          </a:p>
+        </p:txBody>
+      </p:sp>
+      <p:sp>
+        <p:nvSpPr>
+          <p:cNvPr id="11" name="Text 9"/>
+          <p:cNvSpPr/>
+          <p:nvPr/>
+        </p:nvSpPr>
+        <p:spPr>
+          <a:xfrm>
+            <a:off x="6391656" y="1965960"/>
+            <a:ext cx="548640" cy="548640"/>
+          </a:xfrm>
+          <a:prstGeom prst="rect">
+            <a:avLst/>
+          </a:prstGeom>
+          <a:noFill/>
+          <a:ln/>
+        </p:spPr>
+        <p:txBody>
+          <a:bodyPr wrap="square" rtlCol="0" anchor="ctr"/>
+          <a:lstStyle/>
+          <a:p>
+            <a:pPr marL="0" indent="0" algn="ctr">
+              <a:buNone/>
+            </a:pPr>
+            <a:r>
+              <a:rPr lang="en-US" sz="2000" b="1" dirty="0">
+                <a:solidFill>
+                  <a:srgbClr val="FFFFFF"/>
+                </a:solidFill>
+                <a:latin typeface="Arial" pitchFamily="34" charset="0"/>
+                <a:ea typeface="Arial" pitchFamily="34" charset="-122"/>
+                <a:cs typeface="Arial" pitchFamily="34" charset="-120"/>
+              </a:rPr>
+              <a:t>2</a:t>
+            </a:r>
+            <a:endParaRPr lang="en-US" sz="2000" dirty="0"/>
+          </a:p>
+        </p:txBody>
+      </p:sp>
+      <p:sp>
+        <p:nvSpPr>
+          <p:cNvPr id="12" name="Text 10"/>
+          <p:cNvSpPr/>
+          <p:nvPr/>
+        </p:nvSpPr>
+        <p:spPr>
+          <a:xfrm>
+            <a:off x="7077456" y="1170432"/>
+            <a:ext cx="4379976" cy="2139696"/>
+          </a:xfrm>
+          <a:prstGeom prst="rect">
+            <a:avLst/>
+          </a:prstGeom>
+          <a:noFill/>
+          <a:ln/>
+        </p:spPr>
+        <p:txBody>
+          <a:bodyPr wrap="square" rtlCol="0" anchor="ctr"/>
+          <a:lstStyle/>
+          <a:p>
+            <a:pPr marL="0" indent="0">
+              <a:buNone/>
+            </a:pPr>
+            <a:r>
+              <a:rPr lang="en-US" sz="2200" dirty="0">
+                <a:solidFill>
+                  <a:srgbClr val="212121"/>
+                </a:solidFill>
+                <a:latin typeface="Arial" pitchFamily="34" charset="0"/>
+                <a:ea typeface="Arial" pitchFamily="34" charset="-122"/>
+                <a:cs typeface="Arial" pitchFamily="34" charset="-120"/>
+              </a:rPr>
+              <a:t>Tu editor se conecta dentro, guiado por un fichero .devcontainer/devcontainer.json.</a:t>
+            </a:r>
+            <a:endParaRPr lang="en-US" sz="2200" dirty="0"/>
+          </a:p>
+        </p:txBody>
+      </p:sp>
+      <p:sp>
+        <p:nvSpPr>
+          <p:cNvPr id="13" name="Shape 11"/>
+          <p:cNvSpPr/>
+          <p:nvPr/>
+        </p:nvSpPr>
+        <p:spPr>
+          <a:xfrm>
+            <a:off x="548640" y="3611880"/>
+            <a:ext cx="5431536" cy="2286000"/>
+          </a:xfrm>
+          <a:prstGeom prst="roundRect">
+            <a:avLst/>
+          </a:prstGeom>
+          <a:solidFill>
+            <a:srgbClr val="FBEAEA"/>
+          </a:solidFill>
+          <a:ln w="15875">
+            <a:solidFill>
+              <a:srgbClr val="C62828"/>
+            </a:solidFill>
+            <a:prstDash val="solid"/>
+          </a:ln>
+        </p:spPr>
+        <p:txBody>
+          <a:bodyPr/>
+          <a:lstStyle/>
+          <a:p>
+            <a:endParaRPr lang="es-ES"/>
+          </a:p>
+        </p:txBody>
+      </p:sp>
+      <p:sp>
+        <p:nvSpPr>
+          <p:cNvPr id="14" name="Shape 12"/>
+          <p:cNvSpPr/>
+          <p:nvPr/>
+        </p:nvSpPr>
+        <p:spPr>
+          <a:xfrm>
+            <a:off x="731520" y="4480560"/>
+            <a:ext cx="548640" cy="548640"/>
+          </a:xfrm>
+          <a:prstGeom prst="ellipse">
+            <a:avLst/>
+          </a:prstGeom>
+          <a:solidFill>
+            <a:srgbClr val="E64A19"/>
+          </a:solidFill>
+          <a:ln w="12700">
+            <a:solidFill>
+              <a:srgbClr val="E64A19"/>
+            </a:solidFill>
+            <a:prstDash val="solid"/>
+          </a:ln>
+        </p:spPr>
+        <p:txBody>
+          <a:bodyPr/>
+          <a:lstStyle/>
+          <a:p>
+            <a:endParaRPr lang="es-ES"/>
+          </a:p>
+        </p:txBody>
+      </p:sp>
+      <p:sp>
+        <p:nvSpPr>
+          <p:cNvPr id="15" name="Text 13"/>
+          <p:cNvSpPr/>
+          <p:nvPr/>
+        </p:nvSpPr>
+        <p:spPr>
+          <a:xfrm>
+            <a:off x="731520" y="4480560"/>
+            <a:ext cx="548640" cy="548640"/>
+          </a:xfrm>
+          <a:prstGeom prst="rect">
+            <a:avLst/>
+          </a:prstGeom>
+          <a:noFill/>
+          <a:ln/>
+        </p:spPr>
+        <p:txBody>
+          <a:bodyPr wrap="square" rtlCol="0" anchor="ctr"/>
+          <a:lstStyle/>
+          <a:p>
+            <a:pPr marL="0" indent="0" algn="ctr">
+              <a:buNone/>
+            </a:pPr>
+            <a:r>
+              <a:rPr lang="en-US" sz="2000" b="1" dirty="0">
+                <a:solidFill>
+                  <a:srgbClr val="FFFFFF"/>
+                </a:solidFill>
+                <a:latin typeface="Arial" pitchFamily="34" charset="0"/>
+                <a:ea typeface="Arial" pitchFamily="34" charset="-122"/>
+                <a:cs typeface="Arial" pitchFamily="34" charset="-120"/>
+              </a:rPr>
+              <a:t>3</a:t>
+            </a:r>
+            <a:endParaRPr lang="en-US" sz="2000" dirty="0"/>
+          </a:p>
+        </p:txBody>
+      </p:sp>
+      <p:sp>
+        <p:nvSpPr>
+          <p:cNvPr id="16" name="Text 14"/>
+          <p:cNvSpPr/>
+          <p:nvPr/>
+        </p:nvSpPr>
+        <p:spPr>
+          <a:xfrm>
+            <a:off x="1417320" y="3685032"/>
+            <a:ext cx="4379976" cy="2139696"/>
+          </a:xfrm>
+          <a:prstGeom prst="rect">
+            <a:avLst/>
+          </a:prstGeom>
+          <a:noFill/>
+          <a:ln/>
+        </p:spPr>
+        <p:txBody>
+          <a:bodyPr wrap="square" rtlCol="0" anchor="ctr"/>
+          <a:lstStyle/>
+          <a:p>
+            <a:pPr marL="0" indent="0">
+              <a:buNone/>
+            </a:pPr>
+            <a:r>
+              <a:rPr lang="en-US" sz="2200" dirty="0">
+                <a:solidFill>
+                  <a:srgbClr val="212121"/>
+                </a:solidFill>
+                <a:latin typeface="Arial" pitchFamily="34" charset="0"/>
+                <a:ea typeface="Arial" pitchFamily="34" charset="-122"/>
+                <a:cs typeface="Arial" pitchFamily="34" charset="-120"/>
+              </a:rPr>
+              <a:t>La ventana del editor no cambia: lo que cambia es dónde corren la terminal, el depurador y el autocompletado.</a:t>
+            </a:r>
+            <a:endParaRPr lang="en-US" sz="2200" dirty="0"/>
+          </a:p>
+        </p:txBody>
+      </p:sp>
+      <p:sp>
+        <p:nvSpPr>
+          <p:cNvPr id="17" name="Shape 15"/>
+          <p:cNvSpPr/>
+          <p:nvPr/>
+        </p:nvSpPr>
+        <p:spPr>
+          <a:xfrm>
+            <a:off x="6208776" y="3611880"/>
+            <a:ext cx="5431536" cy="2286000"/>
+          </a:xfrm>
+          <a:prstGeom prst="roundRect">
+            <a:avLst/>
+          </a:prstGeom>
+          <a:solidFill>
+            <a:srgbClr val="FBEAEA"/>
+          </a:solidFill>
+          <a:ln w="15875">
+            <a:solidFill>
+              <a:srgbClr val="C62828"/>
+            </a:solidFill>
+            <a:prstDash val="solid"/>
+          </a:ln>
+        </p:spPr>
+        <p:txBody>
+          <a:bodyPr/>
+          <a:lstStyle/>
+          <a:p>
+            <a:endParaRPr lang="es-ES"/>
+          </a:p>
+        </p:txBody>
+      </p:sp>
+      <p:sp>
+        <p:nvSpPr>
+          <p:cNvPr id="18" name="Shape 16"/>
+          <p:cNvSpPr/>
+          <p:nvPr/>
+        </p:nvSpPr>
+        <p:spPr>
+          <a:xfrm>
+            <a:off x="6391656" y="4480560"/>
+            <a:ext cx="548640" cy="548640"/>
+          </a:xfrm>
+          <a:prstGeom prst="ellipse">
+            <a:avLst/>
+          </a:prstGeom>
+          <a:solidFill>
+            <a:srgbClr val="E64A19"/>
+          </a:solidFill>
+          <a:ln w="12700">
+            <a:solidFill>
+              <a:srgbClr val="E64A19"/>
+            </a:solidFill>
+            <a:prstDash val="solid"/>
+          </a:ln>
+        </p:spPr>
+        <p:txBody>
+          <a:bodyPr/>
+          <a:lstStyle/>
+          <a:p>
+            <a:endParaRPr lang="es-ES"/>
+          </a:p>
+        </p:txBody>
+      </p:sp>
+      <p:sp>
+        <p:nvSpPr>
+          <p:cNvPr id="19" name="Text 17"/>
+          <p:cNvSpPr/>
+          <p:nvPr/>
+        </p:nvSpPr>
+        <p:spPr>
+          <a:xfrm>
+            <a:off x="6391656" y="4480560"/>
+            <a:ext cx="548640" cy="548640"/>
+          </a:xfrm>
+          <a:prstGeom prst="rect">
+            <a:avLst/>
+          </a:prstGeom>
+          <a:noFill/>
+          <a:ln/>
+        </p:spPr>
+        <p:txBody>
+          <a:bodyPr wrap="square" rtlCol="0" anchor="ctr"/>
+          <a:lstStyle/>
+          <a:p>
+            <a:pPr marL="0" indent="0" algn="ctr">
+              <a:buNone/>
+            </a:pPr>
+            <a:r>
+              <a:rPr lang="en-US" sz="2000" b="1" dirty="0">
+                <a:solidFill>
+                  <a:srgbClr val="FFFFFF"/>
+                </a:solidFill>
+                <a:latin typeface="Arial" pitchFamily="34" charset="0"/>
+                <a:ea typeface="Arial" pitchFamily="34" charset="-122"/>
+                <a:cs typeface="Arial" pitchFamily="34" charset="-120"/>
+              </a:rPr>
+              <a:t>4</a:t>
+            </a:r>
+            <a:endParaRPr lang="en-US" sz="2000" dirty="0"/>
+          </a:p>
+        </p:txBody>
+      </p:sp>
+      <p:sp>
+        <p:nvSpPr>
+          <p:cNvPr id="20" name="Text 18"/>
+          <p:cNvSpPr/>
+          <p:nvPr/>
+        </p:nvSpPr>
+        <p:spPr>
+          <a:xfrm>
+            <a:off x="7077456" y="3685032"/>
+            <a:ext cx="4379976" cy="2139696"/>
+          </a:xfrm>
+          <a:prstGeom prst="rect">
+            <a:avLst/>
+          </a:prstGeom>
+          <a:noFill/>
+          <a:ln/>
+        </p:spPr>
+        <p:txBody>
+          <a:bodyPr wrap="square" rtlCol="0" anchor="ctr"/>
+          <a:lstStyle/>
+          <a:p>
+            <a:pPr marL="0" indent="0">
+              <a:buNone/>
+            </a:pPr>
+            <a:r>
+              <a:rPr lang="en-US" sz="2200" dirty="0">
+                <a:solidFill>
+                  <a:srgbClr val="212121"/>
+                </a:solidFill>
+                <a:latin typeface="Arial" pitchFamily="34" charset="0"/>
+                <a:ea typeface="Arial" pitchFamily="34" charset="-122"/>
+                <a:cs typeface="Arial" pitchFamily="34" charset="-120"/>
+              </a:rPr>
+              <a:t>El devcontainer.json puede partir de una image suelta o de un servicio de un docker-compose.yml.</a:t>
+            </a:r>
+            <a:endParaRPr lang="en-US" sz="2200" dirty="0"/>
+          </a:p>
+        </p:txBody>
+      </p:sp>
     </p:spTree>
   </p:cSld>
   <p:clrMapOvr>

</xml_diff>